<commit_message>
Update project with MLOps artifacts and rubric deliverables
</commit_message>
<xml_diff>
--- a/slides/DeepHAR_MLOps_Deck.pptx
+++ b/slides/DeepHAR_MLOps_Deck.pptx
@@ -16,6 +16,9 @@
     <p:sldId id="264" r:id="rId15"/>
     <p:sldId id="265" r:id="rId16"/>
     <p:sldId id="266" r:id="rId17"/>
+    <p:sldId id="267" r:id="rId18"/>
+    <p:sldId id="268" r:id="rId19"/>
+    <p:sldId id="269" r:id="rId20"/>
   </p:sldIdLst>
   <p:sldSz cx="12191695" cy="6858000" type="screen4x3"/>
   <p:notesSz cx="6858000" cy="9144000"/>
@@ -3094,7 +3097,7 @@
     <p:bg>
       <p:bgPr>
         <a:solidFill>
-          <a:srgbClr val="F8FAFC"/>
+          <a:srgbClr val="F7F9FC"/>
         </a:solidFill>
         <a:effectLst/>
       </p:bgPr>
@@ -3114,8 +3117,8 @@
         </p:nvSpPr>
         <p:spPr>
           <a:xfrm>
-            <a:off x="731520" y="1280160"/>
-            <a:ext cx="10789920" cy="1097280"/>
+            <a:off x="640080" y="1234440"/>
+            <a:ext cx="10972800" cy="1097280"/>
           </a:xfrm>
           <a:prstGeom prst="rect">
             <a:avLst/>
@@ -3128,13 +3131,14 @@
           </a:bodyPr>
           <a:lstStyle/>
           <a:p>
-            <a:pPr algn="ctr"/>
-            <a:r>
-              <a:rPr sz="5200" b="1">
-                <a:solidFill>
-                  <a:srgbClr val="182B4D"/>
-                </a:solidFill>
-              </a:rPr>
+            <a:pPr>
+              <a:defRPr b="1" sz="4600">
+                <a:solidFill>
+                  <a:srgbClr val="162D4E"/>
+                </a:solidFill>
+              </a:defRPr>
+            </a:pPr>
+            <a:r>
               <a:t>DeepHAR-MLOps</a:t>
             </a:r>
           </a:p>
@@ -3148,8 +3152,8 @@
         </p:nvSpPr>
         <p:spPr>
           <a:xfrm>
-            <a:off x="914400" y="2331720"/>
-            <a:ext cx="10332720" cy="640080"/>
+            <a:off x="667512" y="2240280"/>
+            <a:ext cx="10789920" cy="640080"/>
           </a:xfrm>
           <a:prstGeom prst="rect">
             <a:avLst/>
@@ -3162,14 +3166,15 @@
           </a:bodyPr>
           <a:lstStyle/>
           <a:p>
-            <a:pPr algn="ctr"/>
-            <a:r>
-              <a:rPr sz="2400">
-                <a:solidFill>
-                  <a:srgbClr val="1F77B4"/>
-                </a:solidFill>
-              </a:rPr>
-              <a:t>Sequence-Aware Deep Learning for Smartphone Human Activity Recognition</a:t>
+            <a:pPr>
+              <a:defRPr sz="2200">
+                <a:solidFill>
+                  <a:srgbClr val="2C72B6"/>
+                </a:solidFill>
+              </a:defRPr>
+            </a:pPr>
+            <a:r>
+              <a:t>Foundation-Model-Inspired Human Activity Recognition with Prompted Explanations</a:t>
             </a:r>
           </a:p>
         </p:txBody>
@@ -3182,8 +3187,8 @@
         </p:nvSpPr>
         <p:spPr>
           <a:xfrm>
-            <a:off x="914400" y="3749039"/>
-            <a:ext cx="10332720" cy="457200"/>
+            <a:off x="667512" y="3154680"/>
+            <a:ext cx="10789920" cy="640080"/>
           </a:xfrm>
           <a:prstGeom prst="rect">
             <a:avLst/>
@@ -3196,28 +3201,69 @@
           </a:bodyPr>
           <a:lstStyle/>
           <a:p>
+            <a:pPr>
+              <a:defRPr sz="1600">
+                <a:solidFill>
+                  <a:srgbClr val="282828"/>
+                </a:solidFill>
+              </a:defRPr>
+            </a:pPr>
+            <a:r>
+              <a:t>Vineeth Chandra Sai Kandukuri | Siddharth Rao Kartik | Arshan Bhanage | Soham Jain</a:t>
+            </a:r>
+          </a:p>
+        </p:txBody>
+      </p:sp>
+      <p:sp>
+        <p:nvSpPr>
+          <p:cNvPr id="5" name="Rectangle 4"/>
+          <p:cNvSpPr/>
+          <p:nvPr/>
+        </p:nvSpPr>
+        <p:spPr>
+          <a:xfrm>
+            <a:off x="502920" y="6446520"/>
+            <a:ext cx="11155680" cy="9144"/>
+          </a:xfrm>
+          <a:prstGeom prst="rect">
+            <a:avLst/>
+          </a:prstGeom>
+          <a:solidFill>
+            <a:srgbClr val="D2DCEB"/>
+          </a:solidFill>
+        </p:spPr>
+        <p:style>
+          <a:lnRef idx="1">
+            <a:schemeClr val="accent1"/>
+          </a:lnRef>
+          <a:fillRef idx="3">
+            <a:schemeClr val="accent1"/>
+          </a:fillRef>
+          <a:effectRef idx="2">
+            <a:schemeClr val="accent1"/>
+          </a:effectRef>
+          <a:fontRef idx="minor">
+            <a:schemeClr val="lt1"/>
+          </a:fontRef>
+        </p:style>
+        <p:txBody>
+          <a:bodyPr rtlCol="0" anchor="ctr"/>
+          <a:lstStyle/>
+          <a:p>
             <a:pPr algn="ctr"/>
-            <a:r>
-              <a:rPr sz="2000">
-                <a:solidFill>
-                  <a:srgbClr val="282828"/>
-                </a:solidFill>
-              </a:rPr>
-              <a:t>Vineeth | Siddharth | Arshan | Soham</a:t>
-            </a:r>
-          </a:p>
-        </p:txBody>
-      </p:sp>
-      <p:sp>
-        <p:nvSpPr>
-          <p:cNvPr id="5" name="TextBox 4"/>
+          </a:p>
+        </p:txBody>
+      </p:sp>
+      <p:sp>
+        <p:nvSpPr>
+          <p:cNvPr id="6" name="TextBox 5"/>
           <p:cNvSpPr txBox="1"/>
           <p:nvPr/>
         </p:nvSpPr>
         <p:spPr>
           <a:xfrm>
-            <a:off x="548640" y="6446520"/>
-            <a:ext cx="11064240" cy="228600"/>
+            <a:off x="548640" y="6473952"/>
+            <a:ext cx="10515600" cy="228600"/>
           </a:xfrm>
           <a:prstGeom prst="rect">
             <a:avLst/>
@@ -3230,14 +3276,15 @@
           </a:bodyPr>
           <a:lstStyle/>
           <a:p>
-            <a:pPr algn="r"/>
-            <a:r>
-              <a:rPr sz="900">
-                <a:solidFill>
-                  <a:srgbClr val="646E78"/>
-                </a:solidFill>
-              </a:rPr>
-              <a:t>CMPE 258 | DeepHAR-MLOps</a:t>
+            <a:pPr>
+              <a:defRPr sz="900">
+                <a:solidFill>
+                  <a:srgbClr val="5F6978"/>
+                </a:solidFill>
+              </a:defRPr>
+            </a:pPr>
+            <a:r>
+              <a:t>DeepHAR-MLOps | CMPE Project | 1</a:t>
             </a:r>
           </a:p>
         </p:txBody>
@@ -3256,7 +3303,7 @@
     <p:bg>
       <p:bgPr>
         <a:solidFill>
-          <a:srgbClr val="F8FAFC"/>
+          <a:srgbClr val="F7F9FC"/>
         </a:solidFill>
         <a:effectLst/>
       </p:bgPr>
@@ -3276,8 +3323,8 @@
         </p:nvSpPr>
         <p:spPr>
           <a:xfrm>
-            <a:off x="548640" y="320040"/>
-            <a:ext cx="11064240" cy="640080"/>
+            <a:off x="502920" y="320040"/>
+            <a:ext cx="11155680" cy="658368"/>
           </a:xfrm>
           <a:prstGeom prst="rect">
             <a:avLst/>
@@ -3290,27 +3337,69 @@
           </a:bodyPr>
           <a:lstStyle/>
           <a:p>
-            <a:r>
-              <a:rPr sz="3000" b="1">
-                <a:solidFill>
-                  <a:srgbClr val="182B4D"/>
-                </a:solidFill>
-              </a:rPr>
-              <a:t>Team Contributions</a:t>
-            </a:r>
-          </a:p>
-        </p:txBody>
-      </p:sp>
-      <p:sp>
-        <p:nvSpPr>
-          <p:cNvPr id="3" name="TextBox 2"/>
+            <a:pPr>
+              <a:defRPr b="1" sz="3000">
+                <a:solidFill>
+                  <a:srgbClr val="162D4E"/>
+                </a:solidFill>
+              </a:defRPr>
+            </a:pPr>
+            <a:r>
+              <a:t>Error Analysis</a:t>
+            </a:r>
+          </a:p>
+        </p:txBody>
+      </p:sp>
+      <p:sp>
+        <p:nvSpPr>
+          <p:cNvPr id="3" name="Rectangle 2"/>
+          <p:cNvSpPr/>
+          <p:nvPr/>
+        </p:nvSpPr>
+        <p:spPr>
+          <a:xfrm>
+            <a:off x="502920" y="6446520"/>
+            <a:ext cx="11155680" cy="9144"/>
+          </a:xfrm>
+          <a:prstGeom prst="rect">
+            <a:avLst/>
+          </a:prstGeom>
+          <a:solidFill>
+            <a:srgbClr val="D2DCEB"/>
+          </a:solidFill>
+        </p:spPr>
+        <p:style>
+          <a:lnRef idx="1">
+            <a:schemeClr val="accent1"/>
+          </a:lnRef>
+          <a:fillRef idx="3">
+            <a:schemeClr val="accent1"/>
+          </a:fillRef>
+          <a:effectRef idx="2">
+            <a:schemeClr val="accent1"/>
+          </a:effectRef>
+          <a:fontRef idx="minor">
+            <a:schemeClr val="lt1"/>
+          </a:fontRef>
+        </p:style>
+        <p:txBody>
+          <a:bodyPr rtlCol="0" anchor="ctr"/>
+          <a:lstStyle/>
+          <a:p>
+            <a:pPr algn="ctr"/>
+          </a:p>
+        </p:txBody>
+      </p:sp>
+      <p:sp>
+        <p:nvSpPr>
+          <p:cNvPr id="4" name="TextBox 3"/>
           <p:cNvSpPr txBox="1"/>
           <p:nvPr/>
         </p:nvSpPr>
         <p:spPr>
           <a:xfrm>
-            <a:off x="566928" y="960120"/>
-            <a:ext cx="10972800" cy="320040"/>
+            <a:off x="548640" y="6473952"/>
+            <a:ext cx="10515600" cy="228600"/>
           </a:xfrm>
           <a:prstGeom prst="rect">
             <a:avLst/>
@@ -3323,27 +3412,29 @@
           </a:bodyPr>
           <a:lstStyle/>
           <a:p>
-            <a:r>
-              <a:rPr sz="1500">
-                <a:solidFill>
-                  <a:srgbClr val="282828"/>
-                </a:solidFill>
-              </a:rPr>
-              <a:t>Clear ownership for the final submission</a:t>
-            </a:r>
-          </a:p>
-        </p:txBody>
-      </p:sp>
-      <p:sp>
-        <p:nvSpPr>
-          <p:cNvPr id="4" name="TextBox 3"/>
+            <a:pPr>
+              <a:defRPr sz="900">
+                <a:solidFill>
+                  <a:srgbClr val="5F6978"/>
+                </a:solidFill>
+              </a:defRPr>
+            </a:pPr>
+            <a:r>
+              <a:t>DeepHAR-MLOps | CMPE Project | 10</a:t>
+            </a:r>
+          </a:p>
+        </p:txBody>
+      </p:sp>
+      <p:sp>
+        <p:nvSpPr>
+          <p:cNvPr id="5" name="TextBox 4"/>
           <p:cNvSpPr txBox="1"/>
           <p:nvPr/>
         </p:nvSpPr>
         <p:spPr>
           <a:xfrm>
-            <a:off x="731520" y="1417320"/>
-            <a:ext cx="10789920" cy="4480560"/>
+            <a:off x="777240" y="1417320"/>
+            <a:ext cx="10607040" cy="4754880"/>
           </a:xfrm>
           <a:prstGeom prst="rect">
             <a:avLst/>
@@ -3358,95 +3449,46 @@
           <a:p>
             <a:pPr>
               <a:spcAft>
-                <a:spcPts val="800"/>
+                <a:spcPts val="1000"/>
               </a:spcAft>
-              <a:defRPr sz="2000">
+              <a:defRPr sz="1900">
                 <a:solidFill>
                   <a:srgbClr val="282828"/>
                 </a:solidFill>
               </a:defRPr>
             </a:pPr>
             <a:r>
-              <a:t>Vineeth: model design, training pipeline, baseline notebook, advanced models.</a:t>
+              <a:t>Expected major confusion: SITTING vs STANDING due to similar low-motion patterns.</a:t>
             </a:r>
           </a:p>
           <a:p>
             <a:pPr>
               <a:spcAft>
-                <a:spcPts val="800"/>
+                <a:spcPts val="1000"/>
               </a:spcAft>
-              <a:defRPr sz="2000">
+              <a:defRPr sz="1900">
                 <a:solidFill>
                   <a:srgbClr val="282828"/>
                 </a:solidFill>
               </a:defRPr>
             </a:pPr>
             <a:r>
-              <a:t>Siddharth: MLOps structure, Docker, CI, MLflow/TensorBoard integration.</a:t>
+              <a:t>Walking classes are easier because periodic motion creates clearer temporal signatures.</a:t>
             </a:r>
           </a:p>
           <a:p>
             <a:pPr>
               <a:spcAft>
-                <a:spcPts val="800"/>
+                <a:spcPts val="1000"/>
               </a:spcAft>
-              <a:defRPr sz="2000">
+              <a:defRPr sz="1900">
                 <a:solidFill>
                   <a:srgbClr val="282828"/>
                 </a:solidFill>
               </a:defRPr>
             </a:pPr>
             <a:r>
-              <a:t>Arshan: Gradio app, inference workflow, UX, demo screenshots.</a:t>
-            </a:r>
-          </a:p>
-          <a:p>
-            <a:pPr>
-              <a:spcAft>
-                <a:spcPts val="800"/>
-              </a:spcAft>
-              <a:defRPr sz="2000">
-                <a:solidFill>
-                  <a:srgbClr val="282828"/>
-                </a:solidFill>
-              </a:defRPr>
-            </a:pPr>
-            <a:r>
-              <a:t>Soham: ablation studies, visualizations, report, slides, error analysis.</a:t>
-            </a:r>
-          </a:p>
-        </p:txBody>
-      </p:sp>
-      <p:sp>
-        <p:nvSpPr>
-          <p:cNvPr id="5" name="TextBox 4"/>
-          <p:cNvSpPr txBox="1"/>
-          <p:nvPr/>
-        </p:nvSpPr>
-        <p:spPr>
-          <a:xfrm>
-            <a:off x="548640" y="6446520"/>
-            <a:ext cx="11064240" cy="228600"/>
-          </a:xfrm>
-          <a:prstGeom prst="rect">
-            <a:avLst/>
-          </a:prstGeom>
-          <a:noFill/>
-        </p:spPr>
-        <p:txBody>
-          <a:bodyPr wrap="none">
-            <a:spAutoFit/>
-          </a:bodyPr>
-          <a:lstStyle/>
-          <a:p>
-            <a:pPr algn="r"/>
-            <a:r>
-              <a:rPr sz="900">
-                <a:solidFill>
-                  <a:srgbClr val="646E78"/>
-                </a:solidFill>
-              </a:rPr>
-              <a:t>CMPE 258 | DeepHAR-MLOps</a:t>
+              <a:t>Use normalized confusion matrix and per-class F1 to identify weak classes.</a:t>
             </a:r>
           </a:p>
         </p:txBody>
@@ -3465,7 +3507,7 @@
     <p:bg>
       <p:bgPr>
         <a:solidFill>
-          <a:srgbClr val="F8FAFC"/>
+          <a:srgbClr val="F7F9FC"/>
         </a:solidFill>
         <a:effectLst/>
       </p:bgPr>
@@ -3485,8 +3527,8 @@
         </p:nvSpPr>
         <p:spPr>
           <a:xfrm>
-            <a:off x="548640" y="320040"/>
-            <a:ext cx="11064240" cy="640080"/>
+            <a:off x="502920" y="320040"/>
+            <a:ext cx="11155680" cy="658368"/>
           </a:xfrm>
           <a:prstGeom prst="rect">
             <a:avLst/>
@@ -3499,27 +3541,69 @@
           </a:bodyPr>
           <a:lstStyle/>
           <a:p>
-            <a:r>
-              <a:rPr sz="3000" b="1">
-                <a:solidFill>
-                  <a:srgbClr val="182B4D"/>
-                </a:solidFill>
-              </a:rPr>
-              <a:t>Conclusion</a:t>
-            </a:r>
-          </a:p>
-        </p:txBody>
-      </p:sp>
-      <p:sp>
-        <p:nvSpPr>
-          <p:cNvPr id="3" name="TextBox 2"/>
+            <a:pPr>
+              <a:defRPr b="1" sz="3000">
+                <a:solidFill>
+                  <a:srgbClr val="162D4E"/>
+                </a:solidFill>
+              </a:defRPr>
+            </a:pPr>
+            <a:r>
+              <a:t>MLOps Evidence</a:t>
+            </a:r>
+          </a:p>
+        </p:txBody>
+      </p:sp>
+      <p:sp>
+        <p:nvSpPr>
+          <p:cNvPr id="3" name="Rectangle 2"/>
+          <p:cNvSpPr/>
+          <p:nvPr/>
+        </p:nvSpPr>
+        <p:spPr>
+          <a:xfrm>
+            <a:off x="502920" y="6446520"/>
+            <a:ext cx="11155680" cy="9144"/>
+          </a:xfrm>
+          <a:prstGeom prst="rect">
+            <a:avLst/>
+          </a:prstGeom>
+          <a:solidFill>
+            <a:srgbClr val="D2DCEB"/>
+          </a:solidFill>
+        </p:spPr>
+        <p:style>
+          <a:lnRef idx="1">
+            <a:schemeClr val="accent1"/>
+          </a:lnRef>
+          <a:fillRef idx="3">
+            <a:schemeClr val="accent1"/>
+          </a:fillRef>
+          <a:effectRef idx="2">
+            <a:schemeClr val="accent1"/>
+          </a:effectRef>
+          <a:fontRef idx="minor">
+            <a:schemeClr val="lt1"/>
+          </a:fontRef>
+        </p:style>
+        <p:txBody>
+          <a:bodyPr rtlCol="0" anchor="ctr"/>
+          <a:lstStyle/>
+          <a:p>
+            <a:pPr algn="ctr"/>
+          </a:p>
+        </p:txBody>
+      </p:sp>
+      <p:sp>
+        <p:nvSpPr>
+          <p:cNvPr id="4" name="TextBox 3"/>
           <p:cNvSpPr txBox="1"/>
           <p:nvPr/>
         </p:nvSpPr>
         <p:spPr>
           <a:xfrm>
-            <a:off x="566928" y="960120"/>
-            <a:ext cx="10972800" cy="320040"/>
+            <a:off x="548640" y="6473952"/>
+            <a:ext cx="10515600" cy="228600"/>
           </a:xfrm>
           <a:prstGeom prst="rect">
             <a:avLst/>
@@ -3532,27 +3616,29 @@
           </a:bodyPr>
           <a:lstStyle/>
           <a:p>
-            <a:r>
-              <a:rPr sz="1500">
-                <a:solidFill>
-                  <a:srgbClr val="282828"/>
-                </a:solidFill>
-              </a:rPr>
-              <a:t>Key takeaway</a:t>
-            </a:r>
-          </a:p>
-        </p:txBody>
-      </p:sp>
-      <p:sp>
-        <p:nvSpPr>
-          <p:cNvPr id="4" name="TextBox 3"/>
+            <a:pPr>
+              <a:defRPr sz="900">
+                <a:solidFill>
+                  <a:srgbClr val="5F6978"/>
+                </a:solidFill>
+              </a:defRPr>
+            </a:pPr>
+            <a:r>
+              <a:t>DeepHAR-MLOps | CMPE Project | 11</a:t>
+            </a:r>
+          </a:p>
+        </p:txBody>
+      </p:sp>
+      <p:sp>
+        <p:nvSpPr>
+          <p:cNvPr id="5" name="TextBox 4"/>
           <p:cNvSpPr txBox="1"/>
           <p:nvPr/>
         </p:nvSpPr>
         <p:spPr>
           <a:xfrm>
-            <a:off x="731520" y="1417320"/>
-            <a:ext cx="10789920" cy="4480560"/>
+            <a:off x="777240" y="1417320"/>
+            <a:ext cx="10607040" cy="4754880"/>
           </a:xfrm>
           <a:prstGeom prst="rect">
             <a:avLst/>
@@ -3567,75 +3653,101 @@
           <a:p>
             <a:pPr>
               <a:spcAft>
-                <a:spcPts val="800"/>
+                <a:spcPts val="1000"/>
               </a:spcAft>
-              <a:defRPr sz="2000">
+              <a:defRPr sz="1900">
                 <a:solidFill>
                   <a:srgbClr val="282828"/>
                 </a:solidFill>
               </a:defRPr>
             </a:pPr>
             <a:r>
-              <a:t>Deep learning can classify human activity from short smartphone IMU windows.</a:t>
+              <a:t>Reusable CLIs for training, evaluation, inference, ablations, and sweeps.</a:t>
             </a:r>
           </a:p>
           <a:p>
             <a:pPr>
               <a:spcAft>
-                <a:spcPts val="800"/>
+                <a:spcPts val="1000"/>
               </a:spcAft>
-              <a:defRPr sz="2000">
+              <a:defRPr sz="1900">
                 <a:solidFill>
                   <a:srgbClr val="282828"/>
                 </a:solidFill>
               </a:defRPr>
             </a:pPr>
             <a:r>
-              <a:t>Sequence-aware models outperform the flattened baseline on unseen users.</a:t>
+              <a:t>TensorBoard and optional MLflow tracking.</a:t>
             </a:r>
           </a:p>
           <a:p>
             <a:pPr>
               <a:spcAft>
-                <a:spcPts val="800"/>
+                <a:spcPts val="1000"/>
               </a:spcAft>
-              <a:defRPr sz="2000">
+              <a:defRPr sz="1900">
                 <a:solidFill>
                   <a:srgbClr val="282828"/>
                 </a:solidFill>
               </a:defRPr>
             </a:pPr>
             <a:r>
-              <a:t>The repo is structured as a reproducible MLOps-style project, not only a Colab notebook.</a:t>
+              <a:t>Dockerfile, GitHub Actions, Makefile, DVC-style pipeline, artifact manifest.</a:t>
             </a:r>
           </a:p>
           <a:p>
             <a:pPr>
               <a:spcAft>
-                <a:spcPts val="800"/>
+                <a:spcPts val="1000"/>
               </a:spcAft>
-              <a:defRPr sz="2000">
+              <a:defRPr sz="1900">
                 <a:solidFill>
                   <a:srgbClr val="282828"/>
                 </a:solidFill>
               </a:defRPr>
             </a:pPr>
             <a:r>
-              <a:t>Future work: real-time mobile inference, drift monitoring, and phone-placement robustness.</a:t>
-            </a:r>
-          </a:p>
-        </p:txBody>
-      </p:sp>
-      <p:sp>
-        <p:nvSpPr>
-          <p:cNvPr id="5" name="TextBox 4"/>
+              <a:t>Reference drift profile supports monitoring and retraining discussion.</a:t>
+            </a:r>
+          </a:p>
+        </p:txBody>
+      </p:sp>
+    </p:spTree>
+  </p:cSld>
+  <p:clrMapOvr>
+    <a:masterClrMapping/>
+  </p:clrMapOvr>
+</p:sld>
+</file>
+
+<file path=ppt/slides/slide12.xml><?xml version="1.0" encoding="utf-8"?>
+<p:sld xmlns:a="http://schemas.openxmlformats.org/drawingml/2006/main" xmlns:p="http://schemas.openxmlformats.org/presentationml/2006/main" xmlns:r="http://schemas.openxmlformats.org/officeDocument/2006/relationships">
+  <p:cSld>
+    <p:bg>
+      <p:bgPr>
+        <a:solidFill>
+          <a:srgbClr val="F7F9FC"/>
+        </a:solidFill>
+        <a:effectLst/>
+      </p:bgPr>
+    </p:bg>
+    <p:spTree>
+      <p:nvGrpSpPr>
+        <p:cNvPr id="1" name=""/>
+        <p:cNvGrpSpPr/>
+        <p:nvPr/>
+      </p:nvGrpSpPr>
+      <p:grpSpPr/>
+      <p:sp>
+        <p:nvSpPr>
+          <p:cNvPr id="2" name="TextBox 1"/>
           <p:cNvSpPr txBox="1"/>
           <p:nvPr/>
         </p:nvSpPr>
         <p:spPr>
           <a:xfrm>
-            <a:off x="548640" y="6446520"/>
-            <a:ext cx="11064240" cy="228600"/>
+            <a:off x="502920" y="320040"/>
+            <a:ext cx="11155680" cy="658368"/>
           </a:xfrm>
           <a:prstGeom prst="rect">
             <a:avLst/>
@@ -3648,14 +3760,611 @@
           </a:bodyPr>
           <a:lstStyle/>
           <a:p>
-            <a:pPr algn="r"/>
-            <a:r>
-              <a:rPr sz="900">
-                <a:solidFill>
-                  <a:srgbClr val="646E78"/>
-                </a:solidFill>
-              </a:rPr>
-              <a:t>CMPE 258 | DeepHAR-MLOps</a:t>
+            <a:pPr>
+              <a:defRPr b="1" sz="3000">
+                <a:solidFill>
+                  <a:srgbClr val="162D4E"/>
+                </a:solidFill>
+              </a:defRPr>
+            </a:pPr>
+            <a:r>
+              <a:t>Gradio Demo</a:t>
+            </a:r>
+          </a:p>
+        </p:txBody>
+      </p:sp>
+      <p:sp>
+        <p:nvSpPr>
+          <p:cNvPr id="3" name="Rectangle 2"/>
+          <p:cNvSpPr/>
+          <p:nvPr/>
+        </p:nvSpPr>
+        <p:spPr>
+          <a:xfrm>
+            <a:off x="502920" y="6446520"/>
+            <a:ext cx="11155680" cy="9144"/>
+          </a:xfrm>
+          <a:prstGeom prst="rect">
+            <a:avLst/>
+          </a:prstGeom>
+          <a:solidFill>
+            <a:srgbClr val="D2DCEB"/>
+          </a:solidFill>
+        </p:spPr>
+        <p:style>
+          <a:lnRef idx="1">
+            <a:schemeClr val="accent1"/>
+          </a:lnRef>
+          <a:fillRef idx="3">
+            <a:schemeClr val="accent1"/>
+          </a:fillRef>
+          <a:effectRef idx="2">
+            <a:schemeClr val="accent1"/>
+          </a:effectRef>
+          <a:fontRef idx="minor">
+            <a:schemeClr val="lt1"/>
+          </a:fontRef>
+        </p:style>
+        <p:txBody>
+          <a:bodyPr rtlCol="0" anchor="ctr"/>
+          <a:lstStyle/>
+          <a:p>
+            <a:pPr algn="ctr"/>
+          </a:p>
+        </p:txBody>
+      </p:sp>
+      <p:sp>
+        <p:nvSpPr>
+          <p:cNvPr id="4" name="TextBox 3"/>
+          <p:cNvSpPr txBox="1"/>
+          <p:nvPr/>
+        </p:nvSpPr>
+        <p:spPr>
+          <a:xfrm>
+            <a:off x="548640" y="6473952"/>
+            <a:ext cx="10515600" cy="228600"/>
+          </a:xfrm>
+          <a:prstGeom prst="rect">
+            <a:avLst/>
+          </a:prstGeom>
+          <a:noFill/>
+        </p:spPr>
+        <p:txBody>
+          <a:bodyPr wrap="none">
+            <a:spAutoFit/>
+          </a:bodyPr>
+          <a:lstStyle/>
+          <a:p>
+            <a:pPr>
+              <a:defRPr sz="900">
+                <a:solidFill>
+                  <a:srgbClr val="5F6978"/>
+                </a:solidFill>
+              </a:defRPr>
+            </a:pPr>
+            <a:r>
+              <a:t>DeepHAR-MLOps | CMPE Project | 12</a:t>
+            </a:r>
+          </a:p>
+        </p:txBody>
+      </p:sp>
+      <p:sp>
+        <p:nvSpPr>
+          <p:cNvPr id="5" name="TextBox 4"/>
+          <p:cNvSpPr txBox="1"/>
+          <p:nvPr/>
+        </p:nvSpPr>
+        <p:spPr>
+          <a:xfrm>
+            <a:off x="777240" y="1417320"/>
+            <a:ext cx="10607040" cy="4754880"/>
+          </a:xfrm>
+          <a:prstGeom prst="rect">
+            <a:avLst/>
+          </a:prstGeom>
+          <a:noFill/>
+        </p:spPr>
+        <p:txBody>
+          <a:bodyPr wrap="square">
+            <a:spAutoFit/>
+          </a:bodyPr>
+          <a:lstStyle/>
+          <a:p>
+            <a:pPr>
+              <a:spcAft>
+                <a:spcPts val="1000"/>
+              </a:spcAft>
+              <a:defRPr sz="1900">
+                <a:solidFill>
+                  <a:srgbClr val="282828"/>
+                </a:solidFill>
+              </a:defRPr>
+            </a:pPr>
+            <a:r>
+              <a:t>Upload CSV/NPY or use the included sample window.</a:t>
+            </a:r>
+          </a:p>
+          <a:p>
+            <a:pPr>
+              <a:spcAft>
+                <a:spcPts val="1000"/>
+              </a:spcAft>
+              <a:defRPr sz="1900">
+                <a:solidFill>
+                  <a:srgbClr val="282828"/>
+                </a:solidFill>
+              </a:defRPr>
+            </a:pPr>
+            <a:r>
+              <a:t>Show predicted activity, confidence, probabilities, and sensor-signal plot.</a:t>
+            </a:r>
+          </a:p>
+          <a:p>
+            <a:pPr>
+              <a:spcAft>
+                <a:spcPts val="1000"/>
+              </a:spcAft>
+              <a:defRPr sz="1900">
+                <a:solidFill>
+                  <a:srgbClr val="282828"/>
+                </a:solidFill>
+              </a:defRPr>
+            </a:pPr>
+            <a:r>
+              <a:t>Show prompt-engineered explanation and the exact LLM prompt artifact.</a:t>
+            </a:r>
+          </a:p>
+          <a:p>
+            <a:pPr>
+              <a:spcAft>
+                <a:spcPts val="1000"/>
+              </a:spcAft>
+              <a:defRPr sz="1900">
+                <a:solidFill>
+                  <a:srgbClr val="282828"/>
+                </a:solidFill>
+              </a:defRPr>
+            </a:pPr>
+            <a:r>
+              <a:t>Show drift-monitoring status for production-readiness narrative.</a:t>
+            </a:r>
+          </a:p>
+        </p:txBody>
+      </p:sp>
+    </p:spTree>
+  </p:cSld>
+  <p:clrMapOvr>
+    <a:masterClrMapping/>
+  </p:clrMapOvr>
+</p:sld>
+</file>
+
+<file path=ppt/slides/slide13.xml><?xml version="1.0" encoding="utf-8"?>
+<p:sld xmlns:a="http://schemas.openxmlformats.org/drawingml/2006/main" xmlns:p="http://schemas.openxmlformats.org/presentationml/2006/main" xmlns:r="http://schemas.openxmlformats.org/officeDocument/2006/relationships">
+  <p:cSld>
+    <p:bg>
+      <p:bgPr>
+        <a:solidFill>
+          <a:srgbClr val="F7F9FC"/>
+        </a:solidFill>
+        <a:effectLst/>
+      </p:bgPr>
+    </p:bg>
+    <p:spTree>
+      <p:nvGrpSpPr>
+        <p:cNvPr id="1" name=""/>
+        <p:cNvGrpSpPr/>
+        <p:nvPr/>
+      </p:nvGrpSpPr>
+      <p:grpSpPr/>
+      <p:sp>
+        <p:nvSpPr>
+          <p:cNvPr id="2" name="TextBox 1"/>
+          <p:cNvSpPr txBox="1"/>
+          <p:nvPr/>
+        </p:nvSpPr>
+        <p:spPr>
+          <a:xfrm>
+            <a:off x="502920" y="320040"/>
+            <a:ext cx="11155680" cy="658368"/>
+          </a:xfrm>
+          <a:prstGeom prst="rect">
+            <a:avLst/>
+          </a:prstGeom>
+          <a:noFill/>
+        </p:spPr>
+        <p:txBody>
+          <a:bodyPr wrap="none">
+            <a:spAutoFit/>
+          </a:bodyPr>
+          <a:lstStyle/>
+          <a:p>
+            <a:pPr>
+              <a:defRPr b="1" sz="3000">
+                <a:solidFill>
+                  <a:srgbClr val="162D4E"/>
+                </a:solidFill>
+              </a:defRPr>
+            </a:pPr>
+            <a:r>
+              <a:t>Team Contributions</a:t>
+            </a:r>
+          </a:p>
+        </p:txBody>
+      </p:sp>
+      <p:sp>
+        <p:nvSpPr>
+          <p:cNvPr id="3" name="Rectangle 2"/>
+          <p:cNvSpPr/>
+          <p:nvPr/>
+        </p:nvSpPr>
+        <p:spPr>
+          <a:xfrm>
+            <a:off x="502920" y="6446520"/>
+            <a:ext cx="11155680" cy="9144"/>
+          </a:xfrm>
+          <a:prstGeom prst="rect">
+            <a:avLst/>
+          </a:prstGeom>
+          <a:solidFill>
+            <a:srgbClr val="D2DCEB"/>
+          </a:solidFill>
+        </p:spPr>
+        <p:style>
+          <a:lnRef idx="1">
+            <a:schemeClr val="accent1"/>
+          </a:lnRef>
+          <a:fillRef idx="3">
+            <a:schemeClr val="accent1"/>
+          </a:fillRef>
+          <a:effectRef idx="2">
+            <a:schemeClr val="accent1"/>
+          </a:effectRef>
+          <a:fontRef idx="minor">
+            <a:schemeClr val="lt1"/>
+          </a:fontRef>
+        </p:style>
+        <p:txBody>
+          <a:bodyPr rtlCol="0" anchor="ctr"/>
+          <a:lstStyle/>
+          <a:p>
+            <a:pPr algn="ctr"/>
+          </a:p>
+        </p:txBody>
+      </p:sp>
+      <p:sp>
+        <p:nvSpPr>
+          <p:cNvPr id="4" name="TextBox 3"/>
+          <p:cNvSpPr txBox="1"/>
+          <p:nvPr/>
+        </p:nvSpPr>
+        <p:spPr>
+          <a:xfrm>
+            <a:off x="548640" y="6473952"/>
+            <a:ext cx="10515600" cy="228600"/>
+          </a:xfrm>
+          <a:prstGeom prst="rect">
+            <a:avLst/>
+          </a:prstGeom>
+          <a:noFill/>
+        </p:spPr>
+        <p:txBody>
+          <a:bodyPr wrap="none">
+            <a:spAutoFit/>
+          </a:bodyPr>
+          <a:lstStyle/>
+          <a:p>
+            <a:pPr>
+              <a:defRPr sz="900">
+                <a:solidFill>
+                  <a:srgbClr val="5F6978"/>
+                </a:solidFill>
+              </a:defRPr>
+            </a:pPr>
+            <a:r>
+              <a:t>DeepHAR-MLOps | CMPE Project | 13</a:t>
+            </a:r>
+          </a:p>
+        </p:txBody>
+      </p:sp>
+      <p:sp>
+        <p:nvSpPr>
+          <p:cNvPr id="5" name="TextBox 4"/>
+          <p:cNvSpPr txBox="1"/>
+          <p:nvPr/>
+        </p:nvSpPr>
+        <p:spPr>
+          <a:xfrm>
+            <a:off x="777240" y="1417320"/>
+            <a:ext cx="10607040" cy="4754880"/>
+          </a:xfrm>
+          <a:prstGeom prst="rect">
+            <a:avLst/>
+          </a:prstGeom>
+          <a:noFill/>
+        </p:spPr>
+        <p:txBody>
+          <a:bodyPr wrap="square">
+            <a:spAutoFit/>
+          </a:bodyPr>
+          <a:lstStyle/>
+          <a:p>
+            <a:pPr>
+              <a:spcAft>
+                <a:spcPts val="1000"/>
+              </a:spcAft>
+              <a:defRPr sz="1900">
+                <a:solidFill>
+                  <a:srgbClr val="282828"/>
+                </a:solidFill>
+              </a:defRPr>
+            </a:pPr>
+            <a:r>
+              <a:t>Vineeth: model architectures, training pipeline, metric interpretation.</a:t>
+            </a:r>
+          </a:p>
+          <a:p>
+            <a:pPr>
+              <a:spcAft>
+                <a:spcPts val="1000"/>
+              </a:spcAft>
+              <a:defRPr sz="1900">
+                <a:solidFill>
+                  <a:srgbClr val="282828"/>
+                </a:solidFill>
+              </a:defRPr>
+            </a:pPr>
+            <a:r>
+              <a:t>Siddharth: MLOps structure, Docker, CI, MLflow/TensorBoard, deployment plan.</a:t>
+            </a:r>
+          </a:p>
+          <a:p>
+            <a:pPr>
+              <a:spcAft>
+                <a:spcPts val="1000"/>
+              </a:spcAft>
+              <a:defRPr sz="1900">
+                <a:solidFill>
+                  <a:srgbClr val="282828"/>
+                </a:solidFill>
+              </a:defRPr>
+            </a:pPr>
+            <a:r>
+              <a:t>Arshan: Gradio app, inference UX, prompt explanation display, demo flow.</a:t>
+            </a:r>
+          </a:p>
+          <a:p>
+            <a:pPr>
+              <a:spcAft>
+                <a:spcPts val="1000"/>
+              </a:spcAft>
+              <a:defRPr sz="1900">
+                <a:solidFill>
+                  <a:srgbClr val="282828"/>
+                </a:solidFill>
+              </a:defRPr>
+            </a:pPr>
+            <a:r>
+              <a:t>Soham: ablations, sweeps, visualizations, report, slides, error analysis.</a:t>
+            </a:r>
+          </a:p>
+        </p:txBody>
+      </p:sp>
+    </p:spTree>
+  </p:cSld>
+  <p:clrMapOvr>
+    <a:masterClrMapping/>
+  </p:clrMapOvr>
+</p:sld>
+</file>
+
+<file path=ppt/slides/slide14.xml><?xml version="1.0" encoding="utf-8"?>
+<p:sld xmlns:a="http://schemas.openxmlformats.org/drawingml/2006/main" xmlns:p="http://schemas.openxmlformats.org/presentationml/2006/main" xmlns:r="http://schemas.openxmlformats.org/officeDocument/2006/relationships">
+  <p:cSld>
+    <p:bg>
+      <p:bgPr>
+        <a:solidFill>
+          <a:srgbClr val="F7F9FC"/>
+        </a:solidFill>
+        <a:effectLst/>
+      </p:bgPr>
+    </p:bg>
+    <p:spTree>
+      <p:nvGrpSpPr>
+        <p:cNvPr id="1" name=""/>
+        <p:cNvGrpSpPr/>
+        <p:nvPr/>
+      </p:nvGrpSpPr>
+      <p:grpSpPr/>
+      <p:sp>
+        <p:nvSpPr>
+          <p:cNvPr id="2" name="TextBox 1"/>
+          <p:cNvSpPr txBox="1"/>
+          <p:nvPr/>
+        </p:nvSpPr>
+        <p:spPr>
+          <a:xfrm>
+            <a:off x="502920" y="320040"/>
+            <a:ext cx="11155680" cy="658368"/>
+          </a:xfrm>
+          <a:prstGeom prst="rect">
+            <a:avLst/>
+          </a:prstGeom>
+          <a:noFill/>
+        </p:spPr>
+        <p:txBody>
+          <a:bodyPr wrap="none">
+            <a:spAutoFit/>
+          </a:bodyPr>
+          <a:lstStyle/>
+          <a:p>
+            <a:pPr>
+              <a:defRPr b="1" sz="3000">
+                <a:solidFill>
+                  <a:srgbClr val="162D4E"/>
+                </a:solidFill>
+              </a:defRPr>
+            </a:pPr>
+            <a:r>
+              <a:t>Conclusion and Next Steps</a:t>
+            </a:r>
+          </a:p>
+        </p:txBody>
+      </p:sp>
+      <p:sp>
+        <p:nvSpPr>
+          <p:cNvPr id="3" name="Rectangle 2"/>
+          <p:cNvSpPr/>
+          <p:nvPr/>
+        </p:nvSpPr>
+        <p:spPr>
+          <a:xfrm>
+            <a:off x="502920" y="6446520"/>
+            <a:ext cx="11155680" cy="9144"/>
+          </a:xfrm>
+          <a:prstGeom prst="rect">
+            <a:avLst/>
+          </a:prstGeom>
+          <a:solidFill>
+            <a:srgbClr val="D2DCEB"/>
+          </a:solidFill>
+        </p:spPr>
+        <p:style>
+          <a:lnRef idx="1">
+            <a:schemeClr val="accent1"/>
+          </a:lnRef>
+          <a:fillRef idx="3">
+            <a:schemeClr val="accent1"/>
+          </a:fillRef>
+          <a:effectRef idx="2">
+            <a:schemeClr val="accent1"/>
+          </a:effectRef>
+          <a:fontRef idx="minor">
+            <a:schemeClr val="lt1"/>
+          </a:fontRef>
+        </p:style>
+        <p:txBody>
+          <a:bodyPr rtlCol="0" anchor="ctr"/>
+          <a:lstStyle/>
+          <a:p>
+            <a:pPr algn="ctr"/>
+          </a:p>
+        </p:txBody>
+      </p:sp>
+      <p:sp>
+        <p:nvSpPr>
+          <p:cNvPr id="4" name="TextBox 3"/>
+          <p:cNvSpPr txBox="1"/>
+          <p:nvPr/>
+        </p:nvSpPr>
+        <p:spPr>
+          <a:xfrm>
+            <a:off x="548640" y="6473952"/>
+            <a:ext cx="10515600" cy="228600"/>
+          </a:xfrm>
+          <a:prstGeom prst="rect">
+            <a:avLst/>
+          </a:prstGeom>
+          <a:noFill/>
+        </p:spPr>
+        <p:txBody>
+          <a:bodyPr wrap="none">
+            <a:spAutoFit/>
+          </a:bodyPr>
+          <a:lstStyle/>
+          <a:p>
+            <a:pPr>
+              <a:defRPr sz="900">
+                <a:solidFill>
+                  <a:srgbClr val="5F6978"/>
+                </a:solidFill>
+              </a:defRPr>
+            </a:pPr>
+            <a:r>
+              <a:t>DeepHAR-MLOps | CMPE Project | 14</a:t>
+            </a:r>
+          </a:p>
+        </p:txBody>
+      </p:sp>
+      <p:sp>
+        <p:nvSpPr>
+          <p:cNvPr id="5" name="TextBox 4"/>
+          <p:cNvSpPr txBox="1"/>
+          <p:nvPr/>
+        </p:nvSpPr>
+        <p:spPr>
+          <a:xfrm>
+            <a:off x="777240" y="1417320"/>
+            <a:ext cx="10607040" cy="4754880"/>
+          </a:xfrm>
+          <a:prstGeom prst="rect">
+            <a:avLst/>
+          </a:prstGeom>
+          <a:noFill/>
+        </p:spPr>
+        <p:txBody>
+          <a:bodyPr wrap="square">
+            <a:spAutoFit/>
+          </a:bodyPr>
+          <a:lstStyle/>
+          <a:p>
+            <a:pPr>
+              <a:spcAft>
+                <a:spcPts val="1000"/>
+              </a:spcAft>
+              <a:defRPr sz="1900">
+                <a:solidFill>
+                  <a:srgbClr val="282828"/>
+                </a:solidFill>
+              </a:defRPr>
+            </a:pPr>
+            <a:r>
+              <a:t>Sequence-aware models improve HAR over a flattened baseline.</a:t>
+            </a:r>
+          </a:p>
+          <a:p>
+            <a:pPr>
+              <a:spcAft>
+                <a:spcPts val="1000"/>
+              </a:spcAft>
+              <a:defRPr sz="1900">
+                <a:solidFill>
+                  <a:srgbClr val="282828"/>
+                </a:solidFill>
+              </a:defRPr>
+            </a:pPr>
+            <a:r>
+              <a:t>The repo is now a runnable MLOps project rather than a Colab-only artifact.</a:t>
+            </a:r>
+          </a:p>
+          <a:p>
+            <a:pPr>
+              <a:spcAft>
+                <a:spcPts val="1000"/>
+              </a:spcAft>
+              <a:defRPr sz="1900">
+                <a:solidFill>
+                  <a:srgbClr val="282828"/>
+                </a:solidFill>
+              </a:defRPr>
+            </a:pPr>
+            <a:r>
+              <a:t>Before final submission: run final ablations/sweeps, add screenshots, record videos, publish GitHub URL.</a:t>
+            </a:r>
+          </a:p>
+          <a:p>
+            <a:pPr>
+              <a:spcAft>
+                <a:spcPts val="1000"/>
+              </a:spcAft>
+              <a:defRPr sz="1900">
+                <a:solidFill>
+                  <a:srgbClr val="282828"/>
+                </a:solidFill>
+              </a:defRPr>
+            </a:pPr>
+            <a:r>
+              <a:t>Future: cloud pipeline, drift-triggered retraining, real-time mobile inference, phone-placement robustness.</a:t>
             </a:r>
           </a:p>
         </p:txBody>
@@ -3674,7 +4383,7 @@
     <p:bg>
       <p:bgPr>
         <a:solidFill>
-          <a:srgbClr val="F8FAFC"/>
+          <a:srgbClr val="F7F9FC"/>
         </a:solidFill>
         <a:effectLst/>
       </p:bgPr>
@@ -3694,8 +4403,8 @@
         </p:nvSpPr>
         <p:spPr>
           <a:xfrm>
-            <a:off x="548640" y="320040"/>
-            <a:ext cx="11064240" cy="640080"/>
+            <a:off x="502920" y="320040"/>
+            <a:ext cx="11155680" cy="658368"/>
           </a:xfrm>
           <a:prstGeom prst="rect">
             <a:avLst/>
@@ -3708,12 +4417,14 @@
           </a:bodyPr>
           <a:lstStyle/>
           <a:p>
-            <a:r>
-              <a:rPr sz="3000" b="1">
-                <a:solidFill>
-                  <a:srgbClr val="182B4D"/>
-                </a:solidFill>
-              </a:rPr>
+            <a:pPr>
+              <a:defRPr b="1" sz="3000">
+                <a:solidFill>
+                  <a:srgbClr val="162D4E"/>
+                </a:solidFill>
+              </a:defRPr>
+            </a:pPr>
+            <a:r>
               <a:t>Motivation</a:t>
             </a:r>
           </a:p>
@@ -3721,14 +4432,54 @@
       </p:sp>
       <p:sp>
         <p:nvSpPr>
-          <p:cNvPr id="3" name="TextBox 2"/>
+          <p:cNvPr id="3" name="Rectangle 2"/>
+          <p:cNvSpPr/>
+          <p:nvPr/>
+        </p:nvSpPr>
+        <p:spPr>
+          <a:xfrm>
+            <a:off x="502920" y="6446520"/>
+            <a:ext cx="11155680" cy="9144"/>
+          </a:xfrm>
+          <a:prstGeom prst="rect">
+            <a:avLst/>
+          </a:prstGeom>
+          <a:solidFill>
+            <a:srgbClr val="D2DCEB"/>
+          </a:solidFill>
+        </p:spPr>
+        <p:style>
+          <a:lnRef idx="1">
+            <a:schemeClr val="accent1"/>
+          </a:lnRef>
+          <a:fillRef idx="3">
+            <a:schemeClr val="accent1"/>
+          </a:fillRef>
+          <a:effectRef idx="2">
+            <a:schemeClr val="accent1"/>
+          </a:effectRef>
+          <a:fontRef idx="minor">
+            <a:schemeClr val="lt1"/>
+          </a:fontRef>
+        </p:style>
+        <p:txBody>
+          <a:bodyPr rtlCol="0" anchor="ctr"/>
+          <a:lstStyle/>
+          <a:p>
+            <a:pPr algn="ctr"/>
+          </a:p>
+        </p:txBody>
+      </p:sp>
+      <p:sp>
+        <p:nvSpPr>
+          <p:cNvPr id="4" name="TextBox 3"/>
           <p:cNvSpPr txBox="1"/>
           <p:nvPr/>
         </p:nvSpPr>
         <p:spPr>
           <a:xfrm>
-            <a:off x="566928" y="960120"/>
-            <a:ext cx="10972800" cy="320040"/>
+            <a:off x="548640" y="6473952"/>
+            <a:ext cx="10515600" cy="228600"/>
           </a:xfrm>
           <a:prstGeom prst="rect">
             <a:avLst/>
@@ -3741,27 +4492,29 @@
           </a:bodyPr>
           <a:lstStyle/>
           <a:p>
-            <a:r>
-              <a:rPr sz="1500">
-                <a:solidFill>
-                  <a:srgbClr val="282828"/>
-                </a:solidFill>
-              </a:rPr>
-              <a:t>Recognizing human movement from phone sensors</a:t>
-            </a:r>
-          </a:p>
-        </p:txBody>
-      </p:sp>
-      <p:sp>
-        <p:nvSpPr>
-          <p:cNvPr id="4" name="TextBox 3"/>
+            <a:pPr>
+              <a:defRPr sz="900">
+                <a:solidFill>
+                  <a:srgbClr val="5F6978"/>
+                </a:solidFill>
+              </a:defRPr>
+            </a:pPr>
+            <a:r>
+              <a:t>DeepHAR-MLOps | CMPE Project | 2</a:t>
+            </a:r>
+          </a:p>
+        </p:txBody>
+      </p:sp>
+      <p:sp>
+        <p:nvSpPr>
+          <p:cNvPr id="5" name="TextBox 4"/>
           <p:cNvSpPr txBox="1"/>
           <p:nvPr/>
         </p:nvSpPr>
         <p:spPr>
           <a:xfrm>
-            <a:off x="731520" y="1417320"/>
-            <a:ext cx="10789920" cy="4480560"/>
+            <a:off x="777240" y="1417320"/>
+            <a:ext cx="10607040" cy="4754880"/>
           </a:xfrm>
           <a:prstGeom prst="rect">
             <a:avLst/>
@@ -3776,95 +4529,46 @@
           <a:p>
             <a:pPr>
               <a:spcAft>
-                <a:spcPts val="800"/>
+                <a:spcPts val="1000"/>
               </a:spcAft>
-              <a:defRPr sz="2100">
+              <a:defRPr sz="1900">
                 <a:solidFill>
                   <a:srgbClr val="282828"/>
                 </a:solidFill>
               </a:defRPr>
             </a:pPr>
             <a:r>
-              <a:t>Smartphones already contain accelerometers and gyroscopes.</a:t>
+              <a:t>Smartphones already collect accelerometer and gyroscope signals.</a:t>
             </a:r>
           </a:p>
           <a:p>
             <a:pPr>
               <a:spcAft>
-                <a:spcPts val="800"/>
+                <a:spcPts val="1000"/>
               </a:spcAft>
-              <a:defRPr sz="2100">
+              <a:defRPr sz="1900">
                 <a:solidFill>
                   <a:srgbClr val="282828"/>
                 </a:solidFill>
               </a:defRPr>
             </a:pPr>
             <a:r>
-              <a:t>Activity recognition can support fitness tracking, fall detection, elderly care, and health monitoring.</a:t>
+              <a:t>HAR can support fitness tracking, fall-risk research, elderly care, and context-aware apps.</a:t>
             </a:r>
           </a:p>
           <a:p>
             <a:pPr>
               <a:spcAft>
-                <a:spcPts val="800"/>
+                <a:spcPts val="1000"/>
               </a:spcAft>
-              <a:defRPr sz="2100">
+              <a:defRPr sz="1900">
                 <a:solidFill>
                   <a:srgbClr val="282828"/>
                 </a:solidFill>
               </a:defRPr>
             </a:pPr>
             <a:r>
-              <a:t>The system does not need GPS, camera, microphone, or manual input.</a:t>
-            </a:r>
-          </a:p>
-          <a:p>
-            <a:pPr>
-              <a:spcAft>
-                <a:spcPts val="800"/>
-              </a:spcAft>
-              <a:defRPr sz="2100">
-                <a:solidFill>
-                  <a:srgbClr val="282828"/>
-                </a:solidFill>
-              </a:defRPr>
-            </a:pPr>
-            <a:r>
-              <a:t>Low-power sensor inference is practical for mobile and wearable devices.</a:t>
-            </a:r>
-          </a:p>
-        </p:txBody>
-      </p:sp>
-      <p:sp>
-        <p:nvSpPr>
-          <p:cNvPr id="5" name="TextBox 4"/>
-          <p:cNvSpPr txBox="1"/>
-          <p:nvPr/>
-        </p:nvSpPr>
-        <p:spPr>
-          <a:xfrm>
-            <a:off x="548640" y="6446520"/>
-            <a:ext cx="11064240" cy="228600"/>
-          </a:xfrm>
-          <a:prstGeom prst="rect">
-            <a:avLst/>
-          </a:prstGeom>
-          <a:noFill/>
-        </p:spPr>
-        <p:txBody>
-          <a:bodyPr wrap="none">
-            <a:spAutoFit/>
-          </a:bodyPr>
-          <a:lstStyle/>
-          <a:p>
-            <a:pPr algn="r"/>
-            <a:r>
-              <a:rPr sz="900">
-                <a:solidFill>
-                  <a:srgbClr val="646E78"/>
-                </a:solidFill>
-              </a:rPr>
-              <a:t>CMPE 258 | DeepHAR-MLOps</a:t>
+              <a:t>Sensor-only prediction avoids GPS, camera, microphone, and manual user labels.</a:t>
             </a:r>
           </a:p>
         </p:txBody>
@@ -3883,7 +4587,7 @@
     <p:bg>
       <p:bgPr>
         <a:solidFill>
-          <a:srgbClr val="F8FAFC"/>
+          <a:srgbClr val="F7F9FC"/>
         </a:solidFill>
         <a:effectLst/>
       </p:bgPr>
@@ -3903,8 +4607,8 @@
         </p:nvSpPr>
         <p:spPr>
           <a:xfrm>
-            <a:off x="548640" y="320040"/>
-            <a:ext cx="11064240" cy="640080"/>
+            <a:off x="502920" y="320040"/>
+            <a:ext cx="11155680" cy="658368"/>
           </a:xfrm>
           <a:prstGeom prst="rect">
             <a:avLst/>
@@ -3917,12 +4621,14 @@
           </a:bodyPr>
           <a:lstStyle/>
           <a:p>
-            <a:r>
-              <a:rPr sz="3000" b="1">
-                <a:solidFill>
-                  <a:srgbClr val="182B4D"/>
-                </a:solidFill>
-              </a:rPr>
+            <a:pPr>
+              <a:defRPr b="1" sz="3000">
+                <a:solidFill>
+                  <a:srgbClr val="162D4E"/>
+                </a:solidFill>
+              </a:defRPr>
+            </a:pPr>
+            <a:r>
               <a:t>Problem Statement</a:t>
             </a:r>
           </a:p>
@@ -3930,14 +4636,54 @@
       </p:sp>
       <p:sp>
         <p:nvSpPr>
-          <p:cNvPr id="3" name="TextBox 2"/>
+          <p:cNvPr id="3" name="Rectangle 2"/>
+          <p:cNvSpPr/>
+          <p:nvPr/>
+        </p:nvSpPr>
+        <p:spPr>
+          <a:xfrm>
+            <a:off x="502920" y="6446520"/>
+            <a:ext cx="11155680" cy="9144"/>
+          </a:xfrm>
+          <a:prstGeom prst="rect">
+            <a:avLst/>
+          </a:prstGeom>
+          <a:solidFill>
+            <a:srgbClr val="D2DCEB"/>
+          </a:solidFill>
+        </p:spPr>
+        <p:style>
+          <a:lnRef idx="1">
+            <a:schemeClr val="accent1"/>
+          </a:lnRef>
+          <a:fillRef idx="3">
+            <a:schemeClr val="accent1"/>
+          </a:fillRef>
+          <a:effectRef idx="2">
+            <a:schemeClr val="accent1"/>
+          </a:effectRef>
+          <a:fontRef idx="minor">
+            <a:schemeClr val="lt1"/>
+          </a:fontRef>
+        </p:style>
+        <p:txBody>
+          <a:bodyPr rtlCol="0" anchor="ctr"/>
+          <a:lstStyle/>
+          <a:p>
+            <a:pPr algn="ctr"/>
+          </a:p>
+        </p:txBody>
+      </p:sp>
+      <p:sp>
+        <p:nvSpPr>
+          <p:cNvPr id="4" name="TextBox 3"/>
           <p:cNvSpPr txBox="1"/>
           <p:nvPr/>
         </p:nvSpPr>
         <p:spPr>
           <a:xfrm>
-            <a:off x="566928" y="960120"/>
-            <a:ext cx="10972800" cy="320040"/>
+            <a:off x="548640" y="6473952"/>
+            <a:ext cx="10515600" cy="228600"/>
           </a:xfrm>
           <a:prstGeom prst="rect">
             <a:avLst/>
@@ -3950,27 +4696,29 @@
           </a:bodyPr>
           <a:lstStyle/>
           <a:p>
-            <a:r>
-              <a:rPr sz="1500">
-                <a:solidFill>
-                  <a:srgbClr val="282828"/>
-                </a:solidFill>
-              </a:rPr>
-              <a:t>Predict activity from a short raw sensor window</a:t>
-            </a:r>
-          </a:p>
-        </p:txBody>
-      </p:sp>
-      <p:sp>
-        <p:nvSpPr>
-          <p:cNvPr id="4" name="TextBox 3"/>
+            <a:pPr>
+              <a:defRPr sz="900">
+                <a:solidFill>
+                  <a:srgbClr val="5F6978"/>
+                </a:solidFill>
+              </a:defRPr>
+            </a:pPr>
+            <a:r>
+              <a:t>DeepHAR-MLOps | CMPE Project | 3</a:t>
+            </a:r>
+          </a:p>
+        </p:txBody>
+      </p:sp>
+      <p:sp>
+        <p:nvSpPr>
+          <p:cNvPr id="5" name="TextBox 4"/>
           <p:cNvSpPr txBox="1"/>
           <p:nvPr/>
         </p:nvSpPr>
         <p:spPr>
           <a:xfrm>
-            <a:off x="731520" y="1417320"/>
-            <a:ext cx="10789920" cy="4480560"/>
+            <a:off x="777240" y="1417320"/>
+            <a:ext cx="10607040" cy="4754880"/>
           </a:xfrm>
           <a:prstGeom prst="rect">
             <a:avLst/>
@@ -3985,95 +4733,46 @@
           <a:p>
             <a:pPr>
               <a:spcAft>
-                <a:spcPts val="800"/>
+                <a:spcPts val="1000"/>
               </a:spcAft>
-              <a:defRPr sz="2100">
+              <a:defRPr sz="1900">
                 <a:solidFill>
                   <a:srgbClr val="282828"/>
                 </a:solidFill>
               </a:defRPr>
             </a:pPr>
             <a:r>
-              <a:t>Input: 2.56 second window sampled at 50 Hz.</a:t>
+              <a:t>Input: 2.56-second IMU window with 128 timesteps and 9 channels.</a:t>
             </a:r>
           </a:p>
           <a:p>
             <a:pPr>
               <a:spcAft>
-                <a:spcPts val="800"/>
+                <a:spcPts val="1000"/>
               </a:spcAft>
-              <a:defRPr sz="2100">
+              <a:defRPr sz="1900">
                 <a:solidFill>
                   <a:srgbClr val="282828"/>
                 </a:solidFill>
               </a:defRPr>
             </a:pPr>
             <a:r>
-              <a:t>Shape: 128 timesteps x 9 sensor channels.</a:t>
+              <a:t>Output: one of six activities: walking, stairs up/down, sitting, standing, laying.</a:t>
             </a:r>
           </a:p>
           <a:p>
             <a:pPr>
               <a:spcAft>
-                <a:spcPts val="800"/>
+                <a:spcPts val="1000"/>
               </a:spcAft>
-              <a:defRPr sz="2100">
+              <a:defRPr sz="1900">
                 <a:solidFill>
                   <a:srgbClr val="282828"/>
                 </a:solidFill>
               </a:defRPr>
             </a:pPr>
             <a:r>
-              <a:t>Output: one of six classes: walking, upstairs, downstairs, sitting, standing, laying.</a:t>
-            </a:r>
-          </a:p>
-          <a:p>
-            <a:pPr>
-              <a:spcAft>
-                <a:spcPts val="800"/>
-              </a:spcAft>
-              <a:defRPr sz="2100">
-                <a:solidFill>
-                  <a:srgbClr val="282828"/>
-                </a:solidFill>
-              </a:defRPr>
-            </a:pPr>
-            <a:r>
-              <a:t>Evaluation: subject-based split, so test users are unseen during training.</a:t>
-            </a:r>
-          </a:p>
-        </p:txBody>
-      </p:sp>
-      <p:sp>
-        <p:nvSpPr>
-          <p:cNvPr id="5" name="TextBox 4"/>
-          <p:cNvSpPr txBox="1"/>
-          <p:nvPr/>
-        </p:nvSpPr>
-        <p:spPr>
-          <a:xfrm>
-            <a:off x="548640" y="6446520"/>
-            <a:ext cx="11064240" cy="228600"/>
-          </a:xfrm>
-          <a:prstGeom prst="rect">
-            <a:avLst/>
-          </a:prstGeom>
-          <a:noFill/>
-        </p:spPr>
-        <p:txBody>
-          <a:bodyPr wrap="none">
-            <a:spAutoFit/>
-          </a:bodyPr>
-          <a:lstStyle/>
-          <a:p>
-            <a:pPr algn="r"/>
-            <a:r>
-              <a:rPr sz="900">
-                <a:solidFill>
-                  <a:srgbClr val="646E78"/>
-                </a:solidFill>
-              </a:rPr>
-              <a:t>CMPE 258 | DeepHAR-MLOps</a:t>
+              <a:t>Goal: train models that generalize to unseen subjects, not just random windows.</a:t>
             </a:r>
           </a:p>
         </p:txBody>
@@ -4092,7 +4791,7 @@
     <p:bg>
       <p:bgPr>
         <a:solidFill>
-          <a:srgbClr val="F8FAFC"/>
+          <a:srgbClr val="F7F9FC"/>
         </a:solidFill>
         <a:effectLst/>
       </p:bgPr>
@@ -4112,8 +4811,8 @@
         </p:nvSpPr>
         <p:spPr>
           <a:xfrm>
-            <a:off x="548640" y="320040"/>
-            <a:ext cx="11064240" cy="640080"/>
+            <a:off x="502920" y="320040"/>
+            <a:ext cx="11155680" cy="658368"/>
           </a:xfrm>
           <a:prstGeom prst="rect">
             <a:avLst/>
@@ -4126,27 +4825,69 @@
           </a:bodyPr>
           <a:lstStyle/>
           <a:p>
-            <a:r>
-              <a:rPr sz="3000" b="1">
-                <a:solidFill>
-                  <a:srgbClr val="182B4D"/>
-                </a:solidFill>
-              </a:rPr>
-              <a:t>Dataset</a:t>
-            </a:r>
-          </a:p>
-        </p:txBody>
-      </p:sp>
-      <p:sp>
-        <p:nvSpPr>
-          <p:cNvPr id="3" name="TextBox 2"/>
+            <a:pPr>
+              <a:defRPr b="1" sz="3000">
+                <a:solidFill>
+                  <a:srgbClr val="162D4E"/>
+                </a:solidFill>
+              </a:defRPr>
+            </a:pPr>
+            <a:r>
+              <a:t>Dataset and Preprocessing</a:t>
+            </a:r>
+          </a:p>
+        </p:txBody>
+      </p:sp>
+      <p:sp>
+        <p:nvSpPr>
+          <p:cNvPr id="3" name="Rectangle 2"/>
+          <p:cNvSpPr/>
+          <p:nvPr/>
+        </p:nvSpPr>
+        <p:spPr>
+          <a:xfrm>
+            <a:off x="502920" y="6446520"/>
+            <a:ext cx="11155680" cy="9144"/>
+          </a:xfrm>
+          <a:prstGeom prst="rect">
+            <a:avLst/>
+          </a:prstGeom>
+          <a:solidFill>
+            <a:srgbClr val="D2DCEB"/>
+          </a:solidFill>
+        </p:spPr>
+        <p:style>
+          <a:lnRef idx="1">
+            <a:schemeClr val="accent1"/>
+          </a:lnRef>
+          <a:fillRef idx="3">
+            <a:schemeClr val="accent1"/>
+          </a:fillRef>
+          <a:effectRef idx="2">
+            <a:schemeClr val="accent1"/>
+          </a:effectRef>
+          <a:fontRef idx="minor">
+            <a:schemeClr val="lt1"/>
+          </a:fontRef>
+        </p:style>
+        <p:txBody>
+          <a:bodyPr rtlCol="0" anchor="ctr"/>
+          <a:lstStyle/>
+          <a:p>
+            <a:pPr algn="ctr"/>
+          </a:p>
+        </p:txBody>
+      </p:sp>
+      <p:sp>
+        <p:nvSpPr>
+          <p:cNvPr id="4" name="TextBox 3"/>
           <p:cNvSpPr txBox="1"/>
           <p:nvPr/>
         </p:nvSpPr>
         <p:spPr>
           <a:xfrm>
-            <a:off x="566928" y="960120"/>
-            <a:ext cx="10972800" cy="320040"/>
+            <a:off x="548640" y="6473952"/>
+            <a:ext cx="10515600" cy="228600"/>
           </a:xfrm>
           <a:prstGeom prst="rect">
             <a:avLst/>
@@ -4159,27 +4900,29 @@
           </a:bodyPr>
           <a:lstStyle/>
           <a:p>
-            <a:r>
-              <a:rPr sz="1500">
-                <a:solidFill>
-                  <a:srgbClr val="282828"/>
-                </a:solidFill>
-              </a:rPr>
-              <a:t>UCI Human Activity Recognition using Smartphones</a:t>
-            </a:r>
-          </a:p>
-        </p:txBody>
-      </p:sp>
-      <p:sp>
-        <p:nvSpPr>
-          <p:cNvPr id="4" name="TextBox 3"/>
+            <a:pPr>
+              <a:defRPr sz="900">
+                <a:solidFill>
+                  <a:srgbClr val="5F6978"/>
+                </a:solidFill>
+              </a:defRPr>
+            </a:pPr>
+            <a:r>
+              <a:t>DeepHAR-MLOps | CMPE Project | 4</a:t>
+            </a:r>
+          </a:p>
+        </p:txBody>
+      </p:sp>
+      <p:sp>
+        <p:nvSpPr>
+          <p:cNvPr id="5" name="TextBox 4"/>
           <p:cNvSpPr txBox="1"/>
           <p:nvPr/>
         </p:nvSpPr>
         <p:spPr>
           <a:xfrm>
-            <a:off x="731520" y="1417320"/>
-            <a:ext cx="10789920" cy="4480560"/>
+            <a:off x="777240" y="1417320"/>
+            <a:ext cx="10607040" cy="4754880"/>
           </a:xfrm>
           <a:prstGeom prst="rect">
             <a:avLst/>
@@ -4194,95 +4937,61 @@
           <a:p>
             <a:pPr>
               <a:spcAft>
-                <a:spcPts val="800"/>
+                <a:spcPts val="1000"/>
               </a:spcAft>
-              <a:defRPr sz="2100">
+              <a:defRPr sz="1900">
                 <a:solidFill>
                   <a:srgbClr val="282828"/>
                 </a:solidFill>
               </a:defRPr>
             </a:pPr>
             <a:r>
-              <a:t>30 volunteers performed six activities while carrying a Samsung Galaxy S II at the waist.</a:t>
+              <a:t>UCI Human Activity Recognition dataset with waist-mounted smartphone signals.</a:t>
             </a:r>
           </a:p>
           <a:p>
             <a:pPr>
               <a:spcAft>
-                <a:spcPts val="800"/>
+                <a:spcPts val="1000"/>
               </a:spcAft>
-              <a:defRPr sz="2100">
+              <a:defRPr sz="1900">
                 <a:solidFill>
                   <a:srgbClr val="282828"/>
                 </a:solidFill>
               </a:defRPr>
             </a:pPr>
             <a:r>
-              <a:t>Signals include body acceleration, body gyroscope, and total acceleration on x/y/z axes.</a:t>
+              <a:t>Subject-based train/test split prevents person-level leakage.</a:t>
             </a:r>
           </a:p>
           <a:p>
             <a:pPr>
               <a:spcAft>
-                <a:spcPts val="800"/>
+                <a:spcPts val="1000"/>
               </a:spcAft>
-              <a:defRPr sz="2100">
+              <a:defRPr sz="1900">
                 <a:solidFill>
                   <a:srgbClr val="282828"/>
                 </a:solidFill>
               </a:defRPr>
             </a:pPr>
             <a:r>
-              <a:t>The dataset is already windowed and labeled.</a:t>
+              <a:t>Per-channel z-score normalizer is fitted on training data only.</a:t>
             </a:r>
           </a:p>
           <a:p>
             <a:pPr>
               <a:spcAft>
-                <a:spcPts val="800"/>
+                <a:spcPts val="1000"/>
               </a:spcAft>
-              <a:defRPr sz="2100">
+              <a:defRPr sz="1900">
                 <a:solidFill>
                   <a:srgbClr val="282828"/>
                 </a:solidFill>
               </a:defRPr>
             </a:pPr>
             <a:r>
-              <a:t>Preprocessing: z-score normalization fitted on training data only.</a:t>
-            </a:r>
-          </a:p>
-        </p:txBody>
-      </p:sp>
-      <p:sp>
-        <p:nvSpPr>
-          <p:cNvPr id="5" name="TextBox 4"/>
-          <p:cNvSpPr txBox="1"/>
-          <p:nvPr/>
-        </p:nvSpPr>
-        <p:spPr>
-          <a:xfrm>
-            <a:off x="548640" y="6446520"/>
-            <a:ext cx="11064240" cy="228600"/>
-          </a:xfrm>
-          <a:prstGeom prst="rect">
-            <a:avLst/>
-          </a:prstGeom>
-          <a:noFill/>
-        </p:spPr>
-        <p:txBody>
-          <a:bodyPr wrap="none">
-            <a:spAutoFit/>
-          </a:bodyPr>
-          <a:lstStyle/>
-          <a:p>
-            <a:pPr algn="r"/>
-            <a:r>
-              <a:rPr sz="900">
-                <a:solidFill>
-                  <a:srgbClr val="646E78"/>
-                </a:solidFill>
-              </a:rPr>
-              <a:t>CMPE 258 | DeepHAR-MLOps</a:t>
+              <a:t>Training saves a reference signal profile for inference-time drift checks.</a:t>
             </a:r>
           </a:p>
         </p:txBody>
@@ -4301,7 +5010,7 @@
     <p:bg>
       <p:bgPr>
         <a:solidFill>
-          <a:srgbClr val="F8FAFC"/>
+          <a:srgbClr val="F7F9FC"/>
         </a:solidFill>
         <a:effectLst/>
       </p:bgPr>
@@ -4321,8 +5030,8 @@
         </p:nvSpPr>
         <p:spPr>
           <a:xfrm>
-            <a:off x="548640" y="320040"/>
-            <a:ext cx="11064240" cy="640080"/>
+            <a:off x="502920" y="320040"/>
+            <a:ext cx="11155680" cy="658368"/>
           </a:xfrm>
           <a:prstGeom prst="rect">
             <a:avLst/>
@@ -4335,27 +5044,69 @@
           </a:bodyPr>
           <a:lstStyle/>
           <a:p>
-            <a:r>
-              <a:rPr sz="3000" b="1">
-                <a:solidFill>
-                  <a:srgbClr val="182B4D"/>
-                </a:solidFill>
-              </a:rPr>
-              <a:t>Core Hypothesis</a:t>
-            </a:r>
-          </a:p>
-        </p:txBody>
-      </p:sp>
-      <p:sp>
-        <p:nvSpPr>
-          <p:cNvPr id="3" name="TextBox 2"/>
+            <a:pPr>
+              <a:defRPr b="1" sz="3000">
+                <a:solidFill>
+                  <a:srgbClr val="162D4E"/>
+                </a:solidFill>
+              </a:defRPr>
+            </a:pPr>
+            <a:r>
+              <a:t>End-to-End MLOps Pipeline</a:t>
+            </a:r>
+          </a:p>
+        </p:txBody>
+      </p:sp>
+      <p:sp>
+        <p:nvSpPr>
+          <p:cNvPr id="3" name="Rectangle 2"/>
+          <p:cNvSpPr/>
+          <p:nvPr/>
+        </p:nvSpPr>
+        <p:spPr>
+          <a:xfrm>
+            <a:off x="502920" y="6446520"/>
+            <a:ext cx="11155680" cy="9144"/>
+          </a:xfrm>
+          <a:prstGeom prst="rect">
+            <a:avLst/>
+          </a:prstGeom>
+          <a:solidFill>
+            <a:srgbClr val="D2DCEB"/>
+          </a:solidFill>
+        </p:spPr>
+        <p:style>
+          <a:lnRef idx="1">
+            <a:schemeClr val="accent1"/>
+          </a:lnRef>
+          <a:fillRef idx="3">
+            <a:schemeClr val="accent1"/>
+          </a:fillRef>
+          <a:effectRef idx="2">
+            <a:schemeClr val="accent1"/>
+          </a:effectRef>
+          <a:fontRef idx="minor">
+            <a:schemeClr val="lt1"/>
+          </a:fontRef>
+        </p:style>
+        <p:txBody>
+          <a:bodyPr rtlCol="0" anchor="ctr"/>
+          <a:lstStyle/>
+          <a:p>
+            <a:pPr algn="ctr"/>
+          </a:p>
+        </p:txBody>
+      </p:sp>
+      <p:sp>
+        <p:nvSpPr>
+          <p:cNvPr id="4" name="TextBox 3"/>
           <p:cNvSpPr txBox="1"/>
           <p:nvPr/>
         </p:nvSpPr>
         <p:spPr>
           <a:xfrm>
-            <a:off x="566928" y="960120"/>
-            <a:ext cx="10972800" cy="320040"/>
+            <a:off x="548640" y="6473952"/>
+            <a:ext cx="10515600" cy="228600"/>
           </a:xfrm>
           <a:prstGeom prst="rect">
             <a:avLst/>
@@ -4368,27 +5119,617 @@
           </a:bodyPr>
           <a:lstStyle/>
           <a:p>
-            <a:r>
-              <a:rPr sz="1500">
-                <a:solidFill>
-                  <a:srgbClr val="282828"/>
-                </a:solidFill>
-              </a:rPr>
-              <a:t>Temporal structure matters</a:t>
-            </a:r>
-          </a:p>
-        </p:txBody>
-      </p:sp>
-      <p:sp>
-        <p:nvSpPr>
-          <p:cNvPr id="4" name="TextBox 3"/>
+            <a:pPr>
+              <a:defRPr sz="900">
+                <a:solidFill>
+                  <a:srgbClr val="5F6978"/>
+                </a:solidFill>
+              </a:defRPr>
+            </a:pPr>
+            <a:r>
+              <a:t>DeepHAR-MLOps | CMPE Project | 5</a:t>
+            </a:r>
+          </a:p>
+        </p:txBody>
+      </p:sp>
+      <p:sp>
+        <p:nvSpPr>
+          <p:cNvPr id="5" name="Rounded Rectangle 4"/>
+          <p:cNvSpPr/>
+          <p:nvPr/>
+        </p:nvSpPr>
+        <p:spPr>
+          <a:xfrm>
+            <a:off x="502920" y="2240280"/>
+            <a:ext cx="1325880" cy="731520"/>
+          </a:xfrm>
+          <a:prstGeom prst="roundRect">
+            <a:avLst/>
+          </a:prstGeom>
+          <a:solidFill>
+            <a:srgbClr val="FFFFFF"/>
+          </a:solidFill>
+          <a:ln>
+            <a:solidFill>
+              <a:srgbClr val="2C72B6"/>
+            </a:solidFill>
+          </a:ln>
+        </p:spPr>
+        <p:style>
+          <a:lnRef idx="1">
+            <a:schemeClr val="accent1"/>
+          </a:lnRef>
+          <a:fillRef idx="3">
+            <a:schemeClr val="accent1"/>
+          </a:fillRef>
+          <a:effectRef idx="2">
+            <a:schemeClr val="accent1"/>
+          </a:effectRef>
+          <a:fontRef idx="minor">
+            <a:schemeClr val="lt1"/>
+          </a:fontRef>
+        </p:style>
+        <p:txBody>
+          <a:bodyPr rtlCol="0" anchor="ctr"/>
+          <a:lstStyle/>
+          <a:p>
+            <a:pPr algn="ctr">
+              <a:defRPr b="1" sz="1300">
+                <a:solidFill>
+                  <a:srgbClr val="162D4E"/>
+                </a:solidFill>
+              </a:defRPr>
+            </a:pPr>
+            <a:r>
+              <a:t>Download</a:t>
+            </a:r>
+          </a:p>
+        </p:txBody>
+      </p:sp>
+      <p:sp>
+        <p:nvSpPr>
+          <p:cNvPr id="6" name="TextBox 5"/>
           <p:cNvSpPr txBox="1"/>
           <p:nvPr/>
         </p:nvSpPr>
         <p:spPr>
           <a:xfrm>
-            <a:off x="731520" y="1417320"/>
-            <a:ext cx="10789920" cy="4480560"/>
+            <a:off x="1828800" y="2395728"/>
+            <a:ext cx="320040" cy="274320"/>
+          </a:xfrm>
+          <a:prstGeom prst="rect">
+            <a:avLst/>
+          </a:prstGeom>
+          <a:noFill/>
+        </p:spPr>
+        <p:txBody>
+          <a:bodyPr wrap="none">
+            <a:spAutoFit/>
+          </a:bodyPr>
+          <a:lstStyle/>
+          <a:p>
+            <a:pPr>
+              <a:defRPr sz="1800">
+                <a:solidFill>
+                  <a:srgbClr val="2C72B6"/>
+                </a:solidFill>
+              </a:defRPr>
+            </a:pPr>
+            <a:r>
+              <a:t>→</a:t>
+            </a:r>
+          </a:p>
+        </p:txBody>
+      </p:sp>
+      <p:sp>
+        <p:nvSpPr>
+          <p:cNvPr id="7" name="Rounded Rectangle 6"/>
+          <p:cNvSpPr/>
+          <p:nvPr/>
+        </p:nvSpPr>
+        <p:spPr>
+          <a:xfrm>
+            <a:off x="2148840" y="2240280"/>
+            <a:ext cx="1325880" cy="731520"/>
+          </a:xfrm>
+          <a:prstGeom prst="roundRect">
+            <a:avLst/>
+          </a:prstGeom>
+          <a:solidFill>
+            <a:srgbClr val="FFFFFF"/>
+          </a:solidFill>
+          <a:ln>
+            <a:solidFill>
+              <a:srgbClr val="2C72B6"/>
+            </a:solidFill>
+          </a:ln>
+        </p:spPr>
+        <p:style>
+          <a:lnRef idx="1">
+            <a:schemeClr val="accent1"/>
+          </a:lnRef>
+          <a:fillRef idx="3">
+            <a:schemeClr val="accent1"/>
+          </a:fillRef>
+          <a:effectRef idx="2">
+            <a:schemeClr val="accent1"/>
+          </a:effectRef>
+          <a:fontRef idx="minor">
+            <a:schemeClr val="lt1"/>
+          </a:fontRef>
+        </p:style>
+        <p:txBody>
+          <a:bodyPr rtlCol="0" anchor="ctr"/>
+          <a:lstStyle/>
+          <a:p>
+            <a:pPr algn="ctr">
+              <a:defRPr b="1" sz="1300">
+                <a:solidFill>
+                  <a:srgbClr val="162D4E"/>
+                </a:solidFill>
+              </a:defRPr>
+            </a:pPr>
+            <a:r>
+              <a:t>Normalize</a:t>
+            </a:r>
+          </a:p>
+        </p:txBody>
+      </p:sp>
+      <p:sp>
+        <p:nvSpPr>
+          <p:cNvPr id="8" name="TextBox 7"/>
+          <p:cNvSpPr txBox="1"/>
+          <p:nvPr/>
+        </p:nvSpPr>
+        <p:spPr>
+          <a:xfrm>
+            <a:off x="3474720" y="2395728"/>
+            <a:ext cx="320040" cy="274320"/>
+          </a:xfrm>
+          <a:prstGeom prst="rect">
+            <a:avLst/>
+          </a:prstGeom>
+          <a:noFill/>
+        </p:spPr>
+        <p:txBody>
+          <a:bodyPr wrap="none">
+            <a:spAutoFit/>
+          </a:bodyPr>
+          <a:lstStyle/>
+          <a:p>
+            <a:pPr>
+              <a:defRPr sz="1800">
+                <a:solidFill>
+                  <a:srgbClr val="2C72B6"/>
+                </a:solidFill>
+              </a:defRPr>
+            </a:pPr>
+            <a:r>
+              <a:t>→</a:t>
+            </a:r>
+          </a:p>
+        </p:txBody>
+      </p:sp>
+      <p:sp>
+        <p:nvSpPr>
+          <p:cNvPr id="9" name="Rounded Rectangle 8"/>
+          <p:cNvSpPr/>
+          <p:nvPr/>
+        </p:nvSpPr>
+        <p:spPr>
+          <a:xfrm>
+            <a:off x="3794760" y="2240280"/>
+            <a:ext cx="1325880" cy="731520"/>
+          </a:xfrm>
+          <a:prstGeom prst="roundRect">
+            <a:avLst/>
+          </a:prstGeom>
+          <a:solidFill>
+            <a:srgbClr val="FFFFFF"/>
+          </a:solidFill>
+          <a:ln>
+            <a:solidFill>
+              <a:srgbClr val="2C72B6"/>
+            </a:solidFill>
+          </a:ln>
+        </p:spPr>
+        <p:style>
+          <a:lnRef idx="1">
+            <a:schemeClr val="accent1"/>
+          </a:lnRef>
+          <a:fillRef idx="3">
+            <a:schemeClr val="accent1"/>
+          </a:fillRef>
+          <a:effectRef idx="2">
+            <a:schemeClr val="accent1"/>
+          </a:effectRef>
+          <a:fontRef idx="minor">
+            <a:schemeClr val="lt1"/>
+          </a:fontRef>
+        </p:style>
+        <p:txBody>
+          <a:bodyPr rtlCol="0" anchor="ctr"/>
+          <a:lstStyle/>
+          <a:p>
+            <a:pPr algn="ctr">
+              <a:defRPr b="1" sz="1300">
+                <a:solidFill>
+                  <a:srgbClr val="162D4E"/>
+                </a:solidFill>
+              </a:defRPr>
+            </a:pPr>
+            <a:r>
+              <a:t>Train</a:t>
+            </a:r>
+          </a:p>
+        </p:txBody>
+      </p:sp>
+      <p:sp>
+        <p:nvSpPr>
+          <p:cNvPr id="10" name="TextBox 9"/>
+          <p:cNvSpPr txBox="1"/>
+          <p:nvPr/>
+        </p:nvSpPr>
+        <p:spPr>
+          <a:xfrm>
+            <a:off x="5120640" y="2395728"/>
+            <a:ext cx="320040" cy="274320"/>
+          </a:xfrm>
+          <a:prstGeom prst="rect">
+            <a:avLst/>
+          </a:prstGeom>
+          <a:noFill/>
+        </p:spPr>
+        <p:txBody>
+          <a:bodyPr wrap="none">
+            <a:spAutoFit/>
+          </a:bodyPr>
+          <a:lstStyle/>
+          <a:p>
+            <a:pPr>
+              <a:defRPr sz="1800">
+                <a:solidFill>
+                  <a:srgbClr val="2C72B6"/>
+                </a:solidFill>
+              </a:defRPr>
+            </a:pPr>
+            <a:r>
+              <a:t>→</a:t>
+            </a:r>
+          </a:p>
+        </p:txBody>
+      </p:sp>
+      <p:sp>
+        <p:nvSpPr>
+          <p:cNvPr id="11" name="Rounded Rectangle 10"/>
+          <p:cNvSpPr/>
+          <p:nvPr/>
+        </p:nvSpPr>
+        <p:spPr>
+          <a:xfrm>
+            <a:off x="5440680" y="2240280"/>
+            <a:ext cx="1325880" cy="731520"/>
+          </a:xfrm>
+          <a:prstGeom prst="roundRect">
+            <a:avLst/>
+          </a:prstGeom>
+          <a:solidFill>
+            <a:srgbClr val="FFFFFF"/>
+          </a:solidFill>
+          <a:ln>
+            <a:solidFill>
+              <a:srgbClr val="2C72B6"/>
+            </a:solidFill>
+          </a:ln>
+        </p:spPr>
+        <p:style>
+          <a:lnRef idx="1">
+            <a:schemeClr val="accent1"/>
+          </a:lnRef>
+          <a:fillRef idx="3">
+            <a:schemeClr val="accent1"/>
+          </a:fillRef>
+          <a:effectRef idx="2">
+            <a:schemeClr val="accent1"/>
+          </a:effectRef>
+          <a:fontRef idx="minor">
+            <a:schemeClr val="lt1"/>
+          </a:fontRef>
+        </p:style>
+        <p:txBody>
+          <a:bodyPr rtlCol="0" anchor="ctr"/>
+          <a:lstStyle/>
+          <a:p>
+            <a:pPr algn="ctr">
+              <a:defRPr b="1" sz="1300">
+                <a:solidFill>
+                  <a:srgbClr val="162D4E"/>
+                </a:solidFill>
+              </a:defRPr>
+            </a:pPr>
+            <a:r>
+              <a:t>Evaluate</a:t>
+            </a:r>
+          </a:p>
+        </p:txBody>
+      </p:sp>
+      <p:sp>
+        <p:nvSpPr>
+          <p:cNvPr id="12" name="TextBox 11"/>
+          <p:cNvSpPr txBox="1"/>
+          <p:nvPr/>
+        </p:nvSpPr>
+        <p:spPr>
+          <a:xfrm>
+            <a:off x="6766560" y="2395728"/>
+            <a:ext cx="320040" cy="274320"/>
+          </a:xfrm>
+          <a:prstGeom prst="rect">
+            <a:avLst/>
+          </a:prstGeom>
+          <a:noFill/>
+        </p:spPr>
+        <p:txBody>
+          <a:bodyPr wrap="none">
+            <a:spAutoFit/>
+          </a:bodyPr>
+          <a:lstStyle/>
+          <a:p>
+            <a:pPr>
+              <a:defRPr sz="1800">
+                <a:solidFill>
+                  <a:srgbClr val="2C72B6"/>
+                </a:solidFill>
+              </a:defRPr>
+            </a:pPr>
+            <a:r>
+              <a:t>→</a:t>
+            </a:r>
+          </a:p>
+        </p:txBody>
+      </p:sp>
+      <p:sp>
+        <p:nvSpPr>
+          <p:cNvPr id="13" name="Rounded Rectangle 12"/>
+          <p:cNvSpPr/>
+          <p:nvPr/>
+        </p:nvSpPr>
+        <p:spPr>
+          <a:xfrm>
+            <a:off x="7086600" y="2240280"/>
+            <a:ext cx="1325880" cy="731520"/>
+          </a:xfrm>
+          <a:prstGeom prst="roundRect">
+            <a:avLst/>
+          </a:prstGeom>
+          <a:solidFill>
+            <a:srgbClr val="FFFFFF"/>
+          </a:solidFill>
+          <a:ln>
+            <a:solidFill>
+              <a:srgbClr val="2C72B6"/>
+            </a:solidFill>
+          </a:ln>
+        </p:spPr>
+        <p:style>
+          <a:lnRef idx="1">
+            <a:schemeClr val="accent1"/>
+          </a:lnRef>
+          <a:fillRef idx="3">
+            <a:schemeClr val="accent1"/>
+          </a:fillRef>
+          <a:effectRef idx="2">
+            <a:schemeClr val="accent1"/>
+          </a:effectRef>
+          <a:fontRef idx="minor">
+            <a:schemeClr val="lt1"/>
+          </a:fontRef>
+        </p:style>
+        <p:txBody>
+          <a:bodyPr rtlCol="0" anchor="ctr"/>
+          <a:lstStyle/>
+          <a:p>
+            <a:pPr algn="ctr">
+              <a:defRPr b="1" sz="1300">
+                <a:solidFill>
+                  <a:srgbClr val="162D4E"/>
+                </a:solidFill>
+              </a:defRPr>
+            </a:pPr>
+            <a:r>
+              <a:t>Track</a:t>
+            </a:r>
+          </a:p>
+        </p:txBody>
+      </p:sp>
+      <p:sp>
+        <p:nvSpPr>
+          <p:cNvPr id="14" name="TextBox 13"/>
+          <p:cNvSpPr txBox="1"/>
+          <p:nvPr/>
+        </p:nvSpPr>
+        <p:spPr>
+          <a:xfrm>
+            <a:off x="8412480" y="2395728"/>
+            <a:ext cx="320040" cy="274320"/>
+          </a:xfrm>
+          <a:prstGeom prst="rect">
+            <a:avLst/>
+          </a:prstGeom>
+          <a:noFill/>
+        </p:spPr>
+        <p:txBody>
+          <a:bodyPr wrap="none">
+            <a:spAutoFit/>
+          </a:bodyPr>
+          <a:lstStyle/>
+          <a:p>
+            <a:pPr>
+              <a:defRPr sz="1800">
+                <a:solidFill>
+                  <a:srgbClr val="2C72B6"/>
+                </a:solidFill>
+              </a:defRPr>
+            </a:pPr>
+            <a:r>
+              <a:t>→</a:t>
+            </a:r>
+          </a:p>
+        </p:txBody>
+      </p:sp>
+      <p:sp>
+        <p:nvSpPr>
+          <p:cNvPr id="15" name="Rounded Rectangle 14"/>
+          <p:cNvSpPr/>
+          <p:nvPr/>
+        </p:nvSpPr>
+        <p:spPr>
+          <a:xfrm>
+            <a:off x="8732520" y="2240280"/>
+            <a:ext cx="1325880" cy="731520"/>
+          </a:xfrm>
+          <a:prstGeom prst="roundRect">
+            <a:avLst/>
+          </a:prstGeom>
+          <a:solidFill>
+            <a:srgbClr val="FFFFFF"/>
+          </a:solidFill>
+          <a:ln>
+            <a:solidFill>
+              <a:srgbClr val="2C72B6"/>
+            </a:solidFill>
+          </a:ln>
+        </p:spPr>
+        <p:style>
+          <a:lnRef idx="1">
+            <a:schemeClr val="accent1"/>
+          </a:lnRef>
+          <a:fillRef idx="3">
+            <a:schemeClr val="accent1"/>
+          </a:fillRef>
+          <a:effectRef idx="2">
+            <a:schemeClr val="accent1"/>
+          </a:effectRef>
+          <a:fontRef idx="minor">
+            <a:schemeClr val="lt1"/>
+          </a:fontRef>
+        </p:style>
+        <p:txBody>
+          <a:bodyPr rtlCol="0" anchor="ctr"/>
+          <a:lstStyle/>
+          <a:p>
+            <a:pPr algn="ctr">
+              <a:defRPr b="1" sz="1300">
+                <a:solidFill>
+                  <a:srgbClr val="162D4E"/>
+                </a:solidFill>
+              </a:defRPr>
+            </a:pPr>
+            <a:r>
+              <a:t>Deploy</a:t>
+            </a:r>
+          </a:p>
+        </p:txBody>
+      </p:sp>
+      <p:sp>
+        <p:nvSpPr>
+          <p:cNvPr id="16" name="TextBox 15"/>
+          <p:cNvSpPr txBox="1"/>
+          <p:nvPr/>
+        </p:nvSpPr>
+        <p:spPr>
+          <a:xfrm>
+            <a:off x="10058400" y="2395728"/>
+            <a:ext cx="320040" cy="274320"/>
+          </a:xfrm>
+          <a:prstGeom prst="rect">
+            <a:avLst/>
+          </a:prstGeom>
+          <a:noFill/>
+        </p:spPr>
+        <p:txBody>
+          <a:bodyPr wrap="none">
+            <a:spAutoFit/>
+          </a:bodyPr>
+          <a:lstStyle/>
+          <a:p>
+            <a:pPr>
+              <a:defRPr sz="1800">
+                <a:solidFill>
+                  <a:srgbClr val="2C72B6"/>
+                </a:solidFill>
+              </a:defRPr>
+            </a:pPr>
+            <a:r>
+              <a:t>→</a:t>
+            </a:r>
+          </a:p>
+        </p:txBody>
+      </p:sp>
+      <p:sp>
+        <p:nvSpPr>
+          <p:cNvPr id="17" name="Rounded Rectangle 16"/>
+          <p:cNvSpPr/>
+          <p:nvPr/>
+        </p:nvSpPr>
+        <p:spPr>
+          <a:xfrm>
+            <a:off x="10378440" y="2240280"/>
+            <a:ext cx="1325880" cy="731520"/>
+          </a:xfrm>
+          <a:prstGeom prst="roundRect">
+            <a:avLst/>
+          </a:prstGeom>
+          <a:solidFill>
+            <a:srgbClr val="FFFFFF"/>
+          </a:solidFill>
+          <a:ln>
+            <a:solidFill>
+              <a:srgbClr val="2C72B6"/>
+            </a:solidFill>
+          </a:ln>
+        </p:spPr>
+        <p:style>
+          <a:lnRef idx="1">
+            <a:schemeClr val="accent1"/>
+          </a:lnRef>
+          <a:fillRef idx="3">
+            <a:schemeClr val="accent1"/>
+          </a:fillRef>
+          <a:effectRef idx="2">
+            <a:schemeClr val="accent1"/>
+          </a:effectRef>
+          <a:fontRef idx="minor">
+            <a:schemeClr val="lt1"/>
+          </a:fontRef>
+        </p:style>
+        <p:txBody>
+          <a:bodyPr rtlCol="0" anchor="ctr"/>
+          <a:lstStyle/>
+          <a:p>
+            <a:pPr algn="ctr">
+              <a:defRPr b="1" sz="1300">
+                <a:solidFill>
+                  <a:srgbClr val="162D4E"/>
+                </a:solidFill>
+              </a:defRPr>
+            </a:pPr>
+            <a:r>
+              <a:t>Monitor</a:t>
+            </a:r>
+          </a:p>
+        </p:txBody>
+      </p:sp>
+      <p:sp>
+        <p:nvSpPr>
+          <p:cNvPr id="18" name="TextBox 17"/>
+          <p:cNvSpPr txBox="1"/>
+          <p:nvPr/>
+        </p:nvSpPr>
+        <p:spPr>
+          <a:xfrm>
+            <a:off x="914400" y="3794760"/>
+            <a:ext cx="10515600" cy="1920240"/>
           </a:xfrm>
           <a:prstGeom prst="rect">
             <a:avLst/>
@@ -4405,14 +5746,14 @@
               <a:spcAft>
                 <a:spcPts val="800"/>
               </a:spcAft>
-              <a:defRPr sz="2100">
+              <a:defRPr sz="1800">
                 <a:solidFill>
                   <a:srgbClr val="282828"/>
                 </a:solidFill>
               </a:defRPr>
             </a:pPr>
             <a:r>
-              <a:t>Movement is not just a collection of numbers; the order of the signal matters.</a:t>
+              <a:t>Training saves checkpoint, normalizer, metrics, plots, model summary, and reference drift profile.</a:t>
             </a:r>
           </a:p>
           <a:p>
@@ -4420,14 +5761,14 @@
               <a:spcAft>
                 <a:spcPts val="800"/>
               </a:spcAft>
-              <a:defRPr sz="2100">
+              <a:defRPr sz="1800">
                 <a:solidFill>
                   <a:srgbClr val="282828"/>
                 </a:solidFill>
               </a:defRPr>
             </a:pPr>
             <a:r>
-              <a:t>MLP baseline learns from flattened inputs but has no explicit temporal inductive bias.</a:t>
+              <a:t>Inference website returns prediction, confidence, probabilities, sensor plot, prompt explanation, and drift status.</a:t>
             </a:r>
           </a:p>
           <a:p>
@@ -4435,63 +5776,14 @@
               <a:spcAft>
                 <a:spcPts val="800"/>
               </a:spcAft>
-              <a:defRPr sz="2100">
+              <a:defRPr sz="1800">
                 <a:solidFill>
                   <a:srgbClr val="282828"/>
                 </a:solidFill>
               </a:defRPr>
             </a:pPr>
             <a:r>
-              <a:t>CNNs learn local motion motifs such as periodic walking patterns.</a:t>
-            </a:r>
-          </a:p>
-          <a:p>
-            <a:pPr>
-              <a:spcAft>
-                <a:spcPts val="800"/>
-              </a:spcAft>
-              <a:defRPr sz="2100">
-                <a:solidFill>
-                  <a:srgbClr val="282828"/>
-                </a:solidFill>
-              </a:defRPr>
-            </a:pPr>
-            <a:r>
-              <a:t>LSTM, TCN, and attention models capture longer temporal dependencies.</a:t>
-            </a:r>
-          </a:p>
-        </p:txBody>
-      </p:sp>
-      <p:sp>
-        <p:nvSpPr>
-          <p:cNvPr id="5" name="TextBox 4"/>
-          <p:cNvSpPr txBox="1"/>
-          <p:nvPr/>
-        </p:nvSpPr>
-        <p:spPr>
-          <a:xfrm>
-            <a:off x="548640" y="6446520"/>
-            <a:ext cx="11064240" cy="228600"/>
-          </a:xfrm>
-          <a:prstGeom prst="rect">
-            <a:avLst/>
-          </a:prstGeom>
-          <a:noFill/>
-        </p:spPr>
-        <p:txBody>
-          <a:bodyPr wrap="none">
-            <a:spAutoFit/>
-          </a:bodyPr>
-          <a:lstStyle/>
-          <a:p>
-            <a:pPr algn="r"/>
-            <a:r>
-              <a:rPr sz="900">
-                <a:solidFill>
-                  <a:srgbClr val="646E78"/>
-                </a:solidFill>
-              </a:rPr>
-              <a:t>CMPE 258 | DeepHAR-MLOps</a:t>
+              <a:t>CI, Docker, TensorBoard/MLflow hooks, and artifact manifest support reproducibility.</a:t>
             </a:r>
           </a:p>
         </p:txBody>
@@ -4510,7 +5802,7 @@
     <p:bg>
       <p:bgPr>
         <a:solidFill>
-          <a:srgbClr val="F8FAFC"/>
+          <a:srgbClr val="F7F9FC"/>
         </a:solidFill>
         <a:effectLst/>
       </p:bgPr>
@@ -4530,8 +5822,8 @@
         </p:nvSpPr>
         <p:spPr>
           <a:xfrm>
-            <a:off x="548640" y="320040"/>
-            <a:ext cx="11064240" cy="640080"/>
+            <a:off x="502920" y="320040"/>
+            <a:ext cx="11155680" cy="658368"/>
           </a:xfrm>
           <a:prstGeom prst="rect">
             <a:avLst/>
@@ -4544,27 +5836,69 @@
           </a:bodyPr>
           <a:lstStyle/>
           <a:p>
-            <a:r>
-              <a:rPr sz="3000" b="1">
-                <a:solidFill>
-                  <a:srgbClr val="182B4D"/>
-                </a:solidFill>
-              </a:rPr>
-              <a:t>Model Architectures</a:t>
-            </a:r>
-          </a:p>
-        </p:txBody>
-      </p:sp>
-      <p:sp>
-        <p:nvSpPr>
-          <p:cNvPr id="3" name="TextBox 2"/>
+            <a:pPr>
+              <a:defRPr b="1" sz="3000">
+                <a:solidFill>
+                  <a:srgbClr val="162D4E"/>
+                </a:solidFill>
+              </a:defRPr>
+            </a:pPr>
+            <a:r>
+              <a:t>Model Families</a:t>
+            </a:r>
+          </a:p>
+        </p:txBody>
+      </p:sp>
+      <p:sp>
+        <p:nvSpPr>
+          <p:cNvPr id="3" name="Rectangle 2"/>
+          <p:cNvSpPr/>
+          <p:nvPr/>
+        </p:nvSpPr>
+        <p:spPr>
+          <a:xfrm>
+            <a:off x="502920" y="6446520"/>
+            <a:ext cx="11155680" cy="9144"/>
+          </a:xfrm>
+          <a:prstGeom prst="rect">
+            <a:avLst/>
+          </a:prstGeom>
+          <a:solidFill>
+            <a:srgbClr val="D2DCEB"/>
+          </a:solidFill>
+        </p:spPr>
+        <p:style>
+          <a:lnRef idx="1">
+            <a:schemeClr val="accent1"/>
+          </a:lnRef>
+          <a:fillRef idx="3">
+            <a:schemeClr val="accent1"/>
+          </a:fillRef>
+          <a:effectRef idx="2">
+            <a:schemeClr val="accent1"/>
+          </a:effectRef>
+          <a:fontRef idx="minor">
+            <a:schemeClr val="lt1"/>
+          </a:fontRef>
+        </p:style>
+        <p:txBody>
+          <a:bodyPr rtlCol="0" anchor="ctr"/>
+          <a:lstStyle/>
+          <a:p>
+            <a:pPr algn="ctr"/>
+          </a:p>
+        </p:txBody>
+      </p:sp>
+      <p:sp>
+        <p:nvSpPr>
+          <p:cNvPr id="4" name="TextBox 3"/>
           <p:cNvSpPr txBox="1"/>
           <p:nvPr/>
         </p:nvSpPr>
         <p:spPr>
           <a:xfrm>
-            <a:off x="566928" y="960120"/>
-            <a:ext cx="10972800" cy="320040"/>
+            <a:off x="548640" y="6473952"/>
+            <a:ext cx="10515600" cy="228600"/>
           </a:xfrm>
           <a:prstGeom prst="rect">
             <a:avLst/>
@@ -4577,27 +5911,109 @@
           </a:bodyPr>
           <a:lstStyle/>
           <a:p>
-            <a:r>
-              <a:rPr sz="1500">
-                <a:solidFill>
-                  <a:srgbClr val="282828"/>
-                </a:solidFill>
-              </a:rPr>
-              <a:t>Baseline and sequence-aware models</a:t>
-            </a:r>
-          </a:p>
-        </p:txBody>
-      </p:sp>
-      <p:sp>
-        <p:nvSpPr>
-          <p:cNvPr id="4" name="TextBox 3"/>
+            <a:pPr>
+              <a:defRPr sz="900">
+                <a:solidFill>
+                  <a:srgbClr val="5F6978"/>
+                </a:solidFill>
+              </a:defRPr>
+            </a:pPr>
+            <a:r>
+              <a:t>DeepHAR-MLOps | CMPE Project | 6</a:t>
+            </a:r>
+          </a:p>
+        </p:txBody>
+      </p:sp>
+      <p:sp>
+        <p:nvSpPr>
+          <p:cNvPr id="5" name="Rounded Rectangle 4"/>
+          <p:cNvSpPr/>
+          <p:nvPr/>
+        </p:nvSpPr>
+        <p:spPr>
+          <a:xfrm>
+            <a:off x="685800" y="1325880"/>
+            <a:ext cx="5212080" cy="4892040"/>
+          </a:xfrm>
+          <a:prstGeom prst="roundRect">
+            <a:avLst/>
+          </a:prstGeom>
+          <a:solidFill>
+            <a:srgbClr val="FFFFFF"/>
+          </a:solidFill>
+          <a:ln>
+            <a:solidFill>
+              <a:srgbClr val="E1E8F2"/>
+            </a:solidFill>
+          </a:ln>
+        </p:spPr>
+        <p:style>
+          <a:lnRef idx="1">
+            <a:schemeClr val="accent1"/>
+          </a:lnRef>
+          <a:fillRef idx="3">
+            <a:schemeClr val="accent1"/>
+          </a:fillRef>
+          <a:effectRef idx="2">
+            <a:schemeClr val="accent1"/>
+          </a:effectRef>
+          <a:fontRef idx="minor">
+            <a:schemeClr val="lt1"/>
+          </a:fontRef>
+        </p:style>
+        <p:txBody>
+          <a:bodyPr rtlCol="0" anchor="ctr"/>
+          <a:lstStyle/>
+          <a:p>
+            <a:pPr algn="ctr"/>
+          </a:p>
+        </p:txBody>
+      </p:sp>
+      <p:sp>
+        <p:nvSpPr>
+          <p:cNvPr id="6" name="TextBox 5"/>
           <p:cNvSpPr txBox="1"/>
           <p:nvPr/>
         </p:nvSpPr>
         <p:spPr>
           <a:xfrm>
-            <a:off x="731520" y="1417320"/>
-            <a:ext cx="10789920" cy="4480560"/>
+            <a:off x="960120" y="1554480"/>
+            <a:ext cx="4663440" cy="411480"/>
+          </a:xfrm>
+          <a:prstGeom prst="rect">
+            <a:avLst/>
+          </a:prstGeom>
+          <a:noFill/>
+        </p:spPr>
+        <p:txBody>
+          <a:bodyPr wrap="none">
+            <a:spAutoFit/>
+          </a:bodyPr>
+          <a:lstStyle/>
+          <a:p>
+            <a:pPr>
+              <a:defRPr b="1" sz="2000">
+                <a:solidFill>
+                  <a:srgbClr val="2C72B6"/>
+                </a:solidFill>
+              </a:defRPr>
+            </a:pPr>
+            <a:r>
+              <a:t>Baselines</a:t>
+            </a:r>
+          </a:p>
+        </p:txBody>
+      </p:sp>
+      <p:sp>
+        <p:nvSpPr>
+          <p:cNvPr id="7" name="TextBox 6"/>
+          <p:cNvSpPr txBox="1"/>
+          <p:nvPr/>
+        </p:nvSpPr>
+        <p:spPr>
+          <a:xfrm>
+            <a:off x="1005840" y="2148840"/>
+            <a:ext cx="4617720" cy="3657600"/>
           </a:xfrm>
           <a:prstGeom prst="rect">
             <a:avLst/>
@@ -4614,14 +6030,14 @@
               <a:spcAft>
                 <a:spcPts val="800"/>
               </a:spcAft>
-              <a:defRPr sz="2100">
+              <a:defRPr sz="1600">
                 <a:solidFill>
                   <a:srgbClr val="282828"/>
                 </a:solidFill>
               </a:defRPr>
             </a:pPr>
             <a:r>
-              <a:t>MLP: flattened nonlinear baseline.</a:t>
+              <a:t>MLP: nonlinear baseline without temporal bias</a:t>
             </a:r>
           </a:p>
           <a:p>
@@ -4629,14 +6045,14 @@
               <a:spcAft>
                 <a:spcPts val="800"/>
               </a:spcAft>
-              <a:defRPr sz="2100">
+              <a:defRPr sz="1600">
                 <a:solidFill>
                   <a:srgbClr val="282828"/>
                 </a:solidFill>
               </a:defRPr>
             </a:pPr>
             <a:r>
-              <a:t>1D CNN: local temporal pattern extraction.</a:t>
+              <a:t>1D CNN: local movement motifs</a:t>
             </a:r>
           </a:p>
           <a:p>
@@ -4644,29 +6060,132 @@
               <a:spcAft>
                 <a:spcPts val="800"/>
               </a:spcAft>
-              <a:defRPr sz="2100">
+              <a:defRPr sz="1600">
                 <a:solidFill>
                   <a:srgbClr val="282828"/>
                 </a:solidFill>
               </a:defRPr>
             </a:pPr>
             <a:r>
-              <a:t>CNN-LSTM: convolutional feature extraction followed by sequence modeling.</a:t>
-            </a:r>
-          </a:p>
+              <a:t>CNN-LSTM: convolutional features plus sequence memory</a:t>
+            </a:r>
+          </a:p>
+        </p:txBody>
+      </p:sp>
+      <p:sp>
+        <p:nvSpPr>
+          <p:cNvPr id="8" name="Rounded Rectangle 7"/>
+          <p:cNvSpPr/>
+          <p:nvPr/>
+        </p:nvSpPr>
+        <p:spPr>
+          <a:xfrm>
+            <a:off x="6263640" y="1325880"/>
+            <a:ext cx="5212080" cy="4892040"/>
+          </a:xfrm>
+          <a:prstGeom prst="roundRect">
+            <a:avLst/>
+          </a:prstGeom>
+          <a:solidFill>
+            <a:srgbClr val="FFFFFF"/>
+          </a:solidFill>
+          <a:ln>
+            <a:solidFill>
+              <a:srgbClr val="E1E8F2"/>
+            </a:solidFill>
+          </a:ln>
+        </p:spPr>
+        <p:style>
+          <a:lnRef idx="1">
+            <a:schemeClr val="accent1"/>
+          </a:lnRef>
+          <a:fillRef idx="3">
+            <a:schemeClr val="accent1"/>
+          </a:fillRef>
+          <a:effectRef idx="2">
+            <a:schemeClr val="accent1"/>
+          </a:effectRef>
+          <a:fontRef idx="minor">
+            <a:schemeClr val="lt1"/>
+          </a:fontRef>
+        </p:style>
+        <p:txBody>
+          <a:bodyPr rtlCol="0" anchor="ctr"/>
+          <a:lstStyle/>
+          <a:p>
+            <a:pPr algn="ctr"/>
+          </a:p>
+        </p:txBody>
+      </p:sp>
+      <p:sp>
+        <p:nvSpPr>
+          <p:cNvPr id="9" name="TextBox 8"/>
+          <p:cNvSpPr txBox="1"/>
+          <p:nvPr/>
+        </p:nvSpPr>
+        <p:spPr>
+          <a:xfrm>
+            <a:off x="6537959" y="1554480"/>
+            <a:ext cx="4663440" cy="411480"/>
+          </a:xfrm>
+          <a:prstGeom prst="rect">
+            <a:avLst/>
+          </a:prstGeom>
+          <a:noFill/>
+        </p:spPr>
+        <p:txBody>
+          <a:bodyPr wrap="none">
+            <a:spAutoFit/>
+          </a:bodyPr>
+          <a:lstStyle/>
+          <a:p>
+            <a:pPr>
+              <a:defRPr b="1" sz="2000">
+                <a:solidFill>
+                  <a:srgbClr val="2C72B6"/>
+                </a:solidFill>
+              </a:defRPr>
+            </a:pPr>
+            <a:r>
+              <a:t>Advanced models</a:t>
+            </a:r>
+          </a:p>
+        </p:txBody>
+      </p:sp>
+      <p:sp>
+        <p:nvSpPr>
+          <p:cNvPr id="10" name="TextBox 9"/>
+          <p:cNvSpPr txBox="1"/>
+          <p:nvPr/>
+        </p:nvSpPr>
+        <p:spPr>
+          <a:xfrm>
+            <a:off x="6583679" y="2148840"/>
+            <a:ext cx="4617720" cy="3657600"/>
+          </a:xfrm>
+          <a:prstGeom prst="rect">
+            <a:avLst/>
+          </a:prstGeom>
+          <a:noFill/>
+        </p:spPr>
+        <p:txBody>
+          <a:bodyPr wrap="square">
+            <a:spAutoFit/>
+          </a:bodyPr>
+          <a:lstStyle/>
           <a:p>
             <a:pPr>
               <a:spcAft>
                 <a:spcPts val="800"/>
               </a:spcAft>
-              <a:defRPr sz="2100">
+              <a:defRPr sz="1600">
                 <a:solidFill>
                   <a:srgbClr val="282828"/>
                 </a:solidFill>
               </a:defRPr>
             </a:pPr>
             <a:r>
-              <a:t>TCN: residual dilated temporal convolutions.</a:t>
+              <a:t>TCN: residual dilated temporal convolutions</a:t>
             </a:r>
           </a:p>
           <a:p>
@@ -4674,48 +6193,29 @@
               <a:spcAft>
                 <a:spcPts val="800"/>
               </a:spcAft>
-              <a:defRPr sz="2100">
+              <a:defRPr sz="1600">
                 <a:solidFill>
                   <a:srgbClr val="282828"/>
                 </a:solidFill>
               </a:defRPr>
             </a:pPr>
             <a:r>
-              <a:t>CNN-BiLSTM-Attention: stronger advanced sequence model.</a:t>
-            </a:r>
-          </a:p>
-        </p:txBody>
-      </p:sp>
-      <p:sp>
-        <p:nvSpPr>
-          <p:cNvPr id="5" name="TextBox 4"/>
-          <p:cNvSpPr txBox="1"/>
-          <p:nvPr/>
-        </p:nvSpPr>
-        <p:spPr>
-          <a:xfrm>
-            <a:off x="548640" y="6446520"/>
-            <a:ext cx="11064240" cy="228600"/>
-          </a:xfrm>
-          <a:prstGeom prst="rect">
-            <a:avLst/>
-          </a:prstGeom>
-          <a:noFill/>
-        </p:spPr>
-        <p:txBody>
-          <a:bodyPr wrap="none">
-            <a:spAutoFit/>
-          </a:bodyPr>
-          <a:lstStyle/>
-          <a:p>
-            <a:pPr algn="r"/>
-            <a:r>
-              <a:rPr sz="900">
-                <a:solidFill>
-                  <a:srgbClr val="646E78"/>
-                </a:solidFill>
-              </a:rPr>
-              <a:t>CMPE 258 | DeepHAR-MLOps</a:t>
+              <a:t>CNN-BiLSTM-Attention: bidirectional sequence context</a:t>
+            </a:r>
+          </a:p>
+          <a:p>
+            <a:pPr>
+              <a:spcAft>
+                <a:spcPts val="800"/>
+              </a:spcAft>
+              <a:defRPr sz="1600">
+                <a:solidFill>
+                  <a:srgbClr val="282828"/>
+                </a:solidFill>
+              </a:defRPr>
+            </a:pPr>
+            <a:r>
+              <a:t>Sensor Transformer: self-attention plus positional embeddings</a:t>
             </a:r>
           </a:p>
         </p:txBody>
@@ -4734,7 +6234,7 @@
     <p:bg>
       <p:bgPr>
         <a:solidFill>
-          <a:srgbClr val="F8FAFC"/>
+          <a:srgbClr val="F7F9FC"/>
         </a:solidFill>
         <a:effectLst/>
       </p:bgPr>
@@ -4754,8 +6254,8 @@
         </p:nvSpPr>
         <p:spPr>
           <a:xfrm>
-            <a:off x="548640" y="320040"/>
-            <a:ext cx="11064240" cy="640080"/>
+            <a:off x="502920" y="320040"/>
+            <a:ext cx="11155680" cy="658368"/>
           </a:xfrm>
           <a:prstGeom prst="rect">
             <a:avLst/>
@@ -4768,27 +6268,69 @@
           </a:bodyPr>
           <a:lstStyle/>
           <a:p>
-            <a:r>
-              <a:rPr sz="3000" b="1">
-                <a:solidFill>
-                  <a:srgbClr val="182B4D"/>
-                </a:solidFill>
-              </a:rPr>
-              <a:t>Baseline Results</a:t>
-            </a:r>
-          </a:p>
-        </p:txBody>
-      </p:sp>
-      <p:sp>
-        <p:nvSpPr>
-          <p:cNvPr id="3" name="TextBox 2"/>
+            <a:pPr>
+              <a:defRPr b="1" sz="3000">
+                <a:solidFill>
+                  <a:srgbClr val="162D4E"/>
+                </a:solidFill>
+              </a:defRPr>
+            </a:pPr>
+            <a:r>
+              <a:t>Foundation Model / Prompting Connection</a:t>
+            </a:r>
+          </a:p>
+        </p:txBody>
+      </p:sp>
+      <p:sp>
+        <p:nvSpPr>
+          <p:cNvPr id="3" name="Rectangle 2"/>
+          <p:cNvSpPr/>
+          <p:nvPr/>
+        </p:nvSpPr>
+        <p:spPr>
+          <a:xfrm>
+            <a:off x="502920" y="6446520"/>
+            <a:ext cx="11155680" cy="9144"/>
+          </a:xfrm>
+          <a:prstGeom prst="rect">
+            <a:avLst/>
+          </a:prstGeom>
+          <a:solidFill>
+            <a:srgbClr val="D2DCEB"/>
+          </a:solidFill>
+        </p:spPr>
+        <p:style>
+          <a:lnRef idx="1">
+            <a:schemeClr val="accent1"/>
+          </a:lnRef>
+          <a:fillRef idx="3">
+            <a:schemeClr val="accent1"/>
+          </a:fillRef>
+          <a:effectRef idx="2">
+            <a:schemeClr val="accent1"/>
+          </a:effectRef>
+          <a:fontRef idx="minor">
+            <a:schemeClr val="lt1"/>
+          </a:fontRef>
+        </p:style>
+        <p:txBody>
+          <a:bodyPr rtlCol="0" anchor="ctr"/>
+          <a:lstStyle/>
+          <a:p>
+            <a:pPr algn="ctr"/>
+          </a:p>
+        </p:txBody>
+      </p:sp>
+      <p:sp>
+        <p:nvSpPr>
+          <p:cNvPr id="4" name="TextBox 3"/>
           <p:cNvSpPr txBox="1"/>
           <p:nvPr/>
         </p:nvSpPr>
         <p:spPr>
           <a:xfrm>
-            <a:off x="566928" y="960120"/>
-            <a:ext cx="10972800" cy="320040"/>
+            <a:off x="548640" y="6473952"/>
+            <a:ext cx="10515600" cy="228600"/>
           </a:xfrm>
           <a:prstGeom prst="rect">
             <a:avLst/>
@@ -4801,359 +6343,29 @@
           </a:bodyPr>
           <a:lstStyle/>
           <a:p>
-            <a:r>
-              <a:rPr sz="1500">
-                <a:solidFill>
-                  <a:srgbClr val="282828"/>
-                </a:solidFill>
-              </a:rPr>
-              <a:t>Original notebook metrics on unseen subjects</a:t>
-            </a:r>
-          </a:p>
-        </p:txBody>
-      </p:sp>
-      <p:graphicFrame>
-        <p:nvGraphicFramePr>
-          <p:cNvPr id="4" name="Table 3"/>
-          <p:cNvGraphicFramePr>
-            <a:graphicFrameLocks noGrp="1"/>
-          </p:cNvGraphicFramePr>
-          <p:nvPr/>
-        </p:nvGraphicFramePr>
-        <p:xfrm>
-          <a:off x="685800" y="1417320"/>
-          <a:ext cx="5669280" cy="1920240"/>
-        </p:xfrm>
-        <a:graphic>
-          <a:graphicData uri="http://schemas.openxmlformats.org/drawingml/2006/table">
-            <a:tbl>
-              <a:tblPr firstRow="1" bandRow="1">
-                <a:tableStyleId>{5C22544A-7EE6-4342-B048-85BDC9FD1C3A}</a:tableStyleId>
-              </a:tblPr>
-              <a:tblGrid>
-                <a:gridCol w="1417320"/>
-                <a:gridCol w="1417320"/>
-                <a:gridCol w="1417320"/>
-                <a:gridCol w="1417320"/>
-              </a:tblGrid>
-              <a:tr h="480060">
-                <a:tc>
-                  <a:txBody>
-                    <a:bodyPr/>
-                    <a:lstStyle/>
-                    <a:p>
-                      <a:r>
-                        <a:rPr sz="1400" b="1">
-                          <a:solidFill>
-                            <a:srgbClr val="182B4D"/>
-                          </a:solidFill>
-                        </a:rPr>
-                        <a:t>Model</a:t>
-                      </a:r>
-                    </a:p>
-                  </a:txBody>
-                  <a:tcPr/>
-                </a:tc>
-                <a:tc>
-                  <a:txBody>
-                    <a:bodyPr/>
-                    <a:lstStyle/>
-                    <a:p>
-                      <a:r>
-                        <a:rPr sz="1400" b="1">
-                          <a:solidFill>
-                            <a:srgbClr val="182B4D"/>
-                          </a:solidFill>
-                        </a:rPr>
-                        <a:t>Accuracy</a:t>
-                      </a:r>
-                    </a:p>
-                  </a:txBody>
-                  <a:tcPr/>
-                </a:tc>
-                <a:tc>
-                  <a:txBody>
-                    <a:bodyPr/>
-                    <a:lstStyle/>
-                    <a:p>
-                      <a:r>
-                        <a:rPr sz="1400" b="1">
-                          <a:solidFill>
-                            <a:srgbClr val="182B4D"/>
-                          </a:solidFill>
-                        </a:rPr>
-                        <a:t>Macro F1</a:t>
-                      </a:r>
-                    </a:p>
-                  </a:txBody>
-                  <a:tcPr/>
-                </a:tc>
-                <a:tc>
-                  <a:txBody>
-                    <a:bodyPr/>
-                    <a:lstStyle/>
-                    <a:p>
-                      <a:r>
-                        <a:rPr sz="1400" b="1">
-                          <a:solidFill>
-                            <a:srgbClr val="182B4D"/>
-                          </a:solidFill>
-                        </a:rPr>
-                        <a:t>Train time</a:t>
-                      </a:r>
-                    </a:p>
-                  </a:txBody>
-                  <a:tcPr/>
-                </a:tc>
-              </a:tr>
-              <a:tr h="480060">
-                <a:tc>
-                  <a:txBody>
-                    <a:bodyPr/>
-                    <a:lstStyle/>
-                    <a:p>
-                      <a:r>
-                        <a:rPr sz="1400" b="0">
-                          <a:solidFill>
-                            <a:srgbClr val="282828"/>
-                          </a:solidFill>
-                        </a:rPr>
-                        <a:t>MLP</a:t>
-                      </a:r>
-                    </a:p>
-                  </a:txBody>
-                  <a:tcPr/>
-                </a:tc>
-                <a:tc>
-                  <a:txBody>
-                    <a:bodyPr/>
-                    <a:lstStyle/>
-                    <a:p>
-                      <a:r>
-                        <a:rPr sz="1400" b="0">
-                          <a:solidFill>
-                            <a:srgbClr val="282828"/>
-                          </a:solidFill>
-                        </a:rPr>
-                        <a:t>91.38%</a:t>
-                      </a:r>
-                    </a:p>
-                  </a:txBody>
-                  <a:tcPr/>
-                </a:tc>
-                <a:tc>
-                  <a:txBody>
-                    <a:bodyPr/>
-                    <a:lstStyle/>
-                    <a:p>
-                      <a:r>
-                        <a:rPr sz="1400" b="0">
-                          <a:solidFill>
-                            <a:srgbClr val="282828"/>
-                          </a:solidFill>
-                        </a:rPr>
-                        <a:t>0.9135</a:t>
-                      </a:r>
-                    </a:p>
-                  </a:txBody>
-                  <a:tcPr/>
-                </a:tc>
-                <a:tc>
-                  <a:txBody>
-                    <a:bodyPr/>
-                    <a:lstStyle/>
-                    <a:p>
-                      <a:r>
-                        <a:rPr sz="1400" b="0">
-                          <a:solidFill>
-                            <a:srgbClr val="282828"/>
-                          </a:solidFill>
-                        </a:rPr>
-                        <a:t>82s</a:t>
-                      </a:r>
-                    </a:p>
-                  </a:txBody>
-                  <a:tcPr/>
-                </a:tc>
-              </a:tr>
-              <a:tr h="480060">
-                <a:tc>
-                  <a:txBody>
-                    <a:bodyPr/>
-                    <a:lstStyle/>
-                    <a:p>
-                      <a:r>
-                        <a:rPr sz="1400" b="0">
-                          <a:solidFill>
-                            <a:srgbClr val="282828"/>
-                          </a:solidFill>
-                        </a:rPr>
-                        <a:t>CNN</a:t>
-                      </a:r>
-                    </a:p>
-                  </a:txBody>
-                  <a:tcPr/>
-                </a:tc>
-                <a:tc>
-                  <a:txBody>
-                    <a:bodyPr/>
-                    <a:lstStyle/>
-                    <a:p>
-                      <a:r>
-                        <a:rPr sz="1400" b="0">
-                          <a:solidFill>
-                            <a:srgbClr val="282828"/>
-                          </a:solidFill>
-                        </a:rPr>
-                        <a:t>91.79%</a:t>
-                      </a:r>
-                    </a:p>
-                  </a:txBody>
-                  <a:tcPr/>
-                </a:tc>
-                <a:tc>
-                  <a:txBody>
-                    <a:bodyPr/>
-                    <a:lstStyle/>
-                    <a:p>
-                      <a:r>
-                        <a:rPr sz="1400" b="0">
-                          <a:solidFill>
-                            <a:srgbClr val="282828"/>
-                          </a:solidFill>
-                        </a:rPr>
-                        <a:t>0.9189</a:t>
-                      </a:r>
-                    </a:p>
-                  </a:txBody>
-                  <a:tcPr/>
-                </a:tc>
-                <a:tc>
-                  <a:txBody>
-                    <a:bodyPr/>
-                    <a:lstStyle/>
-                    <a:p>
-                      <a:r>
-                        <a:rPr sz="1400" b="0">
-                          <a:solidFill>
-                            <a:srgbClr val="282828"/>
-                          </a:solidFill>
-                        </a:rPr>
-                        <a:t>529s</a:t>
-                      </a:r>
-                    </a:p>
-                  </a:txBody>
-                  <a:tcPr/>
-                </a:tc>
-              </a:tr>
-              <a:tr h="480060">
-                <a:tc>
-                  <a:txBody>
-                    <a:bodyPr/>
-                    <a:lstStyle/>
-                    <a:p>
-                      <a:r>
-                        <a:rPr sz="1400" b="0">
-                          <a:solidFill>
-                            <a:srgbClr val="282828"/>
-                          </a:solidFill>
-                        </a:rPr>
-                        <a:t>CNN-LSTM</a:t>
-                      </a:r>
-                    </a:p>
-                  </a:txBody>
-                  <a:tcPr/>
-                </a:tc>
-                <a:tc>
-                  <a:txBody>
-                    <a:bodyPr/>
-                    <a:lstStyle/>
-                    <a:p>
-                      <a:r>
-                        <a:rPr sz="1400" b="0">
-                          <a:solidFill>
-                            <a:srgbClr val="282828"/>
-                          </a:solidFill>
-                        </a:rPr>
-                        <a:t>93.25%</a:t>
-                      </a:r>
-                    </a:p>
-                  </a:txBody>
-                  <a:tcPr/>
-                </a:tc>
-                <a:tc>
-                  <a:txBody>
-                    <a:bodyPr/>
-                    <a:lstStyle/>
-                    <a:p>
-                      <a:r>
-                        <a:rPr sz="1400" b="0">
-                          <a:solidFill>
-                            <a:srgbClr val="282828"/>
-                          </a:solidFill>
-                        </a:rPr>
-                        <a:t>0.9335</a:t>
-                      </a:r>
-                    </a:p>
-                  </a:txBody>
-                  <a:tcPr/>
-                </a:tc>
-                <a:tc>
-                  <a:txBody>
-                    <a:bodyPr/>
-                    <a:lstStyle/>
-                    <a:p>
-                      <a:r>
-                        <a:rPr sz="1400" b="0">
-                          <a:solidFill>
-                            <a:srgbClr val="282828"/>
-                          </a:solidFill>
-                        </a:rPr>
-                        <a:t>829s</a:t>
-                      </a:r>
-                    </a:p>
-                  </a:txBody>
-                  <a:tcPr/>
-                </a:tc>
-              </a:tr>
-            </a:tbl>
-          </a:graphicData>
-        </a:graphic>
-      </p:graphicFrame>
-      <p:pic>
-        <p:nvPicPr>
-          <p:cNvPr id="5" name="Picture 4" descr="baseline_model_comparison.png"/>
-          <p:cNvPicPr>
-            <a:picLocks noChangeAspect="1"/>
-          </p:cNvPicPr>
-          <p:nvPr/>
-        </p:nvPicPr>
-        <p:blipFill>
-          <a:blip r:embed="rId2"/>
-          <a:stretch>
-            <a:fillRect/>
-          </a:stretch>
-        </p:blipFill>
-        <p:spPr>
-          <a:xfrm>
-            <a:off x="6629400" y="1234440"/>
-            <a:ext cx="4754880" cy="2971800"/>
-          </a:xfrm>
-          <a:prstGeom prst="rect">
-            <a:avLst/>
-          </a:prstGeom>
-        </p:spPr>
-      </p:pic>
-      <p:sp>
-        <p:nvSpPr>
-          <p:cNvPr id="6" name="TextBox 5"/>
+            <a:pPr>
+              <a:defRPr sz="900">
+                <a:solidFill>
+                  <a:srgbClr val="5F6978"/>
+                </a:solidFill>
+              </a:defRPr>
+            </a:pPr>
+            <a:r>
+              <a:t>DeepHAR-MLOps | CMPE Project | 7</a:t>
+            </a:r>
+          </a:p>
+        </p:txBody>
+      </p:sp>
+      <p:sp>
+        <p:nvSpPr>
+          <p:cNvPr id="5" name="TextBox 4"/>
           <p:cNvSpPr txBox="1"/>
           <p:nvPr/>
         </p:nvSpPr>
         <p:spPr>
           <a:xfrm>
-            <a:off x="777240" y="3840480"/>
-            <a:ext cx="10424160" cy="1097280"/>
+            <a:off x="777240" y="1417320"/>
+            <a:ext cx="10607040" cy="4754880"/>
           </a:xfrm>
           <a:prstGeom prst="rect">
             <a:avLst/>
@@ -5168,7 +6380,7 @@
           <a:p>
             <a:pPr>
               <a:spcAft>
-                <a:spcPts val="800"/>
+                <a:spcPts val="1000"/>
               </a:spcAft>
               <a:defRPr sz="1900">
                 <a:solidFill>
@@ -5177,13 +6389,13 @@
               </a:defRPr>
             </a:pPr>
             <a:r>
-              <a:t>CNN-LSTM is the best initial baseline.</a:t>
+              <a:t>Sensor-transformer adds a foundation-model-inspired encoder for time-series windows.</a:t>
             </a:r>
           </a:p>
           <a:p>
             <a:pPr>
               <a:spcAft>
-                <a:spcPts val="800"/>
+                <a:spcPts val="1000"/>
               </a:spcAft>
               <a:defRPr sz="1900">
                 <a:solidFill>
@@ -5192,41 +6404,37 @@
               </a:defRPr>
             </a:pPr>
             <a:r>
-              <a:t>Static postures remain hardest: sitting vs standing confusion.</a:t>
-            </a:r>
-          </a:p>
-        </p:txBody>
-      </p:sp>
-      <p:sp>
-        <p:nvSpPr>
-          <p:cNvPr id="7" name="TextBox 6"/>
-          <p:cNvSpPr txBox="1"/>
-          <p:nvPr/>
-        </p:nvSpPr>
-        <p:spPr>
-          <a:xfrm>
-            <a:off x="548640" y="6446520"/>
-            <a:ext cx="11064240" cy="228600"/>
-          </a:xfrm>
-          <a:prstGeom prst="rect">
-            <a:avLst/>
-          </a:prstGeom>
-          <a:noFill/>
-        </p:spPr>
-        <p:txBody>
-          <a:bodyPr wrap="none">
-            <a:spAutoFit/>
-          </a:bodyPr>
-          <a:lstStyle/>
-          <a:p>
-            <a:pPr algn="r"/>
-            <a:r>
-              <a:rPr sz="900">
-                <a:solidFill>
-                  <a:srgbClr val="646E78"/>
-                </a:solidFill>
-              </a:rPr>
-              <a:t>CMPE 258 | DeepHAR-MLOps</a:t>
+              <a:t>Prompt layer turns prediction context into an LLM-ready system/user prompt.</a:t>
+            </a:r>
+          </a:p>
+          <a:p>
+            <a:pPr>
+              <a:spcAft>
+                <a:spcPts val="1000"/>
+              </a:spcAft>
+              <a:defRPr sz="1900">
+                <a:solidFill>
+                  <a:srgbClr val="282828"/>
+                </a:solidFill>
+              </a:defRPr>
+            </a:pPr>
+            <a:r>
+              <a:t>Deterministic fallback explanation keeps the demo reproducible without API keys.</a:t>
+            </a:r>
+          </a:p>
+          <a:p>
+            <a:pPr>
+              <a:spcAft>
+                <a:spcPts val="1000"/>
+              </a:spcAft>
+              <a:defRPr sz="1900">
+                <a:solidFill>
+                  <a:srgbClr val="282828"/>
+                </a:solidFill>
+              </a:defRPr>
+            </a:pPr>
+            <a:r>
+              <a:t>Prompt includes confidence, top probabilities, sensor stats, caveat, and reliability next step.</a:t>
             </a:r>
           </a:p>
         </p:txBody>
@@ -5245,7 +6453,7 @@
     <p:bg>
       <p:bgPr>
         <a:solidFill>
-          <a:srgbClr val="F8FAFC"/>
+          <a:srgbClr val="F7F9FC"/>
         </a:solidFill>
         <a:effectLst/>
       </p:bgPr>
@@ -5265,8 +6473,8 @@
         </p:nvSpPr>
         <p:spPr>
           <a:xfrm>
-            <a:off x="548640" y="320040"/>
-            <a:ext cx="11064240" cy="640080"/>
+            <a:off x="502920" y="320040"/>
+            <a:ext cx="11155680" cy="658368"/>
           </a:xfrm>
           <a:prstGeom prst="rect">
             <a:avLst/>
@@ -5279,13 +6487,15 @@
           </a:bodyPr>
           <a:lstStyle/>
           <a:p>
-            <a:r>
-              <a:rPr sz="3000" b="1">
-                <a:solidFill>
-                  <a:srgbClr val="182B4D"/>
-                </a:solidFill>
-              </a:rPr>
-              <a:t>Ablation Studies</a:t>
+            <a:pPr>
+              <a:defRPr b="1" sz="3000">
+                <a:solidFill>
+                  <a:srgbClr val="162D4E"/>
+                </a:solidFill>
+              </a:defRPr>
+            </a:pPr>
+            <a:r>
+              <a:t>Baseline Results</a:t>
             </a:r>
           </a:p>
         </p:txBody>
@@ -5298,8 +6508,8 @@
         </p:nvSpPr>
         <p:spPr>
           <a:xfrm>
-            <a:off x="566928" y="960120"/>
-            <a:ext cx="10972800" cy="320040"/>
+            <a:off x="530352" y="960120"/>
+            <a:ext cx="10972800" cy="347472"/>
           </a:xfrm>
           <a:prstGeom prst="rect">
             <a:avLst/>
@@ -5312,97 +6522,56 @@
           </a:bodyPr>
           <a:lstStyle/>
           <a:p>
-            <a:r>
-              <a:rPr sz="1500">
-                <a:solidFill>
-                  <a:srgbClr val="282828"/>
-                </a:solidFill>
-              </a:rPr>
-              <a:t>Experiments that show what matters</a:t>
-            </a:r>
-          </a:p>
-        </p:txBody>
-      </p:sp>
-      <p:sp>
-        <p:nvSpPr>
-          <p:cNvPr id="4" name="TextBox 3"/>
-          <p:cNvSpPr txBox="1"/>
-          <p:nvPr/>
-        </p:nvSpPr>
-        <p:spPr>
-          <a:xfrm>
-            <a:off x="731520" y="1417320"/>
-            <a:ext cx="10789920" cy="4480560"/>
+            <a:pPr>
+              <a:defRPr sz="1400">
+                <a:solidFill>
+                  <a:srgbClr val="5F6978"/>
+                </a:solidFill>
+              </a:defRPr>
+            </a:pPr>
+            <a:r>
+              <a:t>UCI HAR subject-based test split</a:t>
+            </a:r>
+          </a:p>
+        </p:txBody>
+      </p:sp>
+      <p:sp>
+        <p:nvSpPr>
+          <p:cNvPr id="4" name="Rectangle 3"/>
+          <p:cNvSpPr/>
+          <p:nvPr/>
+        </p:nvSpPr>
+        <p:spPr>
+          <a:xfrm>
+            <a:off x="502920" y="6446520"/>
+            <a:ext cx="11155680" cy="9144"/>
           </a:xfrm>
           <a:prstGeom prst="rect">
             <a:avLst/>
           </a:prstGeom>
-          <a:noFill/>
-        </p:spPr>
-        <p:txBody>
-          <a:bodyPr wrap="square">
-            <a:spAutoFit/>
-          </a:bodyPr>
-          <a:lstStyle/>
-          <a:p>
-            <a:pPr>
-              <a:spcAft>
-                <a:spcPts val="800"/>
-              </a:spcAft>
-              <a:defRPr sz="2000">
-                <a:solidFill>
-                  <a:srgbClr val="282828"/>
-                </a:solidFill>
-              </a:defRPr>
-            </a:pPr>
-            <a:r>
-              <a:t>Architecture: MLP vs CNN vs CNN-LSTM vs TCN vs attention.</a:t>
-            </a:r>
-          </a:p>
-          <a:p>
-            <a:pPr>
-              <a:spcAft>
-                <a:spcPts val="800"/>
-              </a:spcAft>
-              <a:defRPr sz="2000">
-                <a:solidFill>
-                  <a:srgbClr val="282828"/>
-                </a:solidFill>
-              </a:defRPr>
-            </a:pPr>
-            <a:r>
-              <a:t>Sensor subset: all sensors vs accelerometer only vs gyroscope only.</a:t>
-            </a:r>
-          </a:p>
-          <a:p>
-            <a:pPr>
-              <a:spcAft>
-                <a:spcPts val="800"/>
-              </a:spcAft>
-              <a:defRPr sz="2000">
-                <a:solidFill>
-                  <a:srgbClr val="282828"/>
-                </a:solidFill>
-              </a:defRPr>
-            </a:pPr>
-            <a:r>
-              <a:t>Augmentation: no augmentation vs jitter, scaling, and time masking.</a:t>
-            </a:r>
-          </a:p>
-          <a:p>
-            <a:pPr>
-              <a:spcAft>
-                <a:spcPts val="800"/>
-              </a:spcAft>
-              <a:defRPr sz="2000">
-                <a:solidFill>
-                  <a:srgbClr val="282828"/>
-                </a:solidFill>
-              </a:defRPr>
-            </a:pPr>
-            <a:r>
-              <a:t>Hyperparameters: learning rate, dropout, batch size, and hidden units.</a:t>
-            </a:r>
+          <a:solidFill>
+            <a:srgbClr val="D2DCEB"/>
+          </a:solidFill>
+        </p:spPr>
+        <p:style>
+          <a:lnRef idx="1">
+            <a:schemeClr val="accent1"/>
+          </a:lnRef>
+          <a:fillRef idx="3">
+            <a:schemeClr val="accent1"/>
+          </a:fillRef>
+          <a:effectRef idx="2">
+            <a:schemeClr val="accent1"/>
+          </a:effectRef>
+          <a:fontRef idx="minor">
+            <a:schemeClr val="lt1"/>
+          </a:fontRef>
+        </p:style>
+        <p:txBody>
+          <a:bodyPr rtlCol="0" anchor="ctr"/>
+          <a:lstStyle/>
+          <a:p>
+            <a:pPr algn="ctr"/>
           </a:p>
         </p:txBody>
       </p:sp>
@@ -5414,8 +6583,8 @@
         </p:nvSpPr>
         <p:spPr>
           <a:xfrm>
-            <a:off x="548640" y="6446520"/>
-            <a:ext cx="11064240" cy="228600"/>
+            <a:off x="548640" y="6473952"/>
+            <a:ext cx="10515600" cy="228600"/>
           </a:xfrm>
           <a:prstGeom prst="rect">
             <a:avLst/>
@@ -5428,14 +6597,478 @@
           </a:bodyPr>
           <a:lstStyle/>
           <a:p>
-            <a:pPr algn="r"/>
-            <a:r>
-              <a:rPr sz="900">
-                <a:solidFill>
-                  <a:srgbClr val="646E78"/>
-                </a:solidFill>
-              </a:rPr>
-              <a:t>CMPE 258 | DeepHAR-MLOps</a:t>
+            <a:pPr>
+              <a:defRPr sz="900">
+                <a:solidFill>
+                  <a:srgbClr val="5F6978"/>
+                </a:solidFill>
+              </a:defRPr>
+            </a:pPr>
+            <a:r>
+              <a:t>DeepHAR-MLOps | CMPE Project | 8</a:t>
+            </a:r>
+          </a:p>
+        </p:txBody>
+      </p:sp>
+      <p:graphicFrame>
+        <p:nvGraphicFramePr>
+          <p:cNvPr id="6" name="Table 5"/>
+          <p:cNvGraphicFramePr>
+            <a:graphicFrameLocks noGrp="1"/>
+          </p:cNvGraphicFramePr>
+          <p:nvPr/>
+        </p:nvGraphicFramePr>
+        <p:xfrm>
+          <a:off x="731520" y="1463040"/>
+          <a:ext cx="5394960" cy="1828800"/>
+        </p:xfrm>
+        <a:graphic>
+          <a:graphicData uri="http://schemas.openxmlformats.org/drawingml/2006/table">
+            <a:tbl>
+              <a:tblPr firstRow="1" bandRow="1">
+                <a:tableStyleId>{5C22544A-7EE6-4342-B048-85BDC9FD1C3A}</a:tableStyleId>
+              </a:tblPr>
+              <a:tblGrid>
+                <a:gridCol w="1348740"/>
+                <a:gridCol w="1348740"/>
+                <a:gridCol w="1348740"/>
+                <a:gridCol w="1348740"/>
+              </a:tblGrid>
+              <a:tr h="457200">
+                <a:tc>
+                  <a:txBody>
+                    <a:bodyPr/>
+                    <a:lstStyle/>
+                    <a:p>
+                      <a:pPr>
+                        <a:defRPr sz="1400" b="1">
+                          <a:solidFill>
+                            <a:srgbClr val="162D4E"/>
+                          </a:solidFill>
+                        </a:defRPr>
+                      </a:pPr>
+                      <a:r>
+                        <a:t>Model</a:t>
+                      </a:r>
+                    </a:p>
+                  </a:txBody>
+                  <a:tcPr>
+                    <a:solidFill>
+                      <a:srgbClr val="E6EEF8"/>
+                    </a:solidFill>
+                  </a:tcPr>
+                </a:tc>
+                <a:tc>
+                  <a:txBody>
+                    <a:bodyPr/>
+                    <a:lstStyle/>
+                    <a:p>
+                      <a:pPr>
+                        <a:defRPr sz="1400" b="1">
+                          <a:solidFill>
+                            <a:srgbClr val="162D4E"/>
+                          </a:solidFill>
+                        </a:defRPr>
+                      </a:pPr>
+                      <a:r>
+                        <a:t>Accuracy</a:t>
+                      </a:r>
+                    </a:p>
+                  </a:txBody>
+                  <a:tcPr>
+                    <a:solidFill>
+                      <a:srgbClr val="E6EEF8"/>
+                    </a:solidFill>
+                  </a:tcPr>
+                </a:tc>
+                <a:tc>
+                  <a:txBody>
+                    <a:bodyPr/>
+                    <a:lstStyle/>
+                    <a:p>
+                      <a:pPr>
+                        <a:defRPr sz="1400" b="1">
+                          <a:solidFill>
+                            <a:srgbClr val="162D4E"/>
+                          </a:solidFill>
+                        </a:defRPr>
+                      </a:pPr>
+                      <a:r>
+                        <a:t>Macro F1</a:t>
+                      </a:r>
+                    </a:p>
+                  </a:txBody>
+                  <a:tcPr>
+                    <a:solidFill>
+                      <a:srgbClr val="E6EEF8"/>
+                    </a:solidFill>
+                  </a:tcPr>
+                </a:tc>
+                <a:tc>
+                  <a:txBody>
+                    <a:bodyPr/>
+                    <a:lstStyle/>
+                    <a:p>
+                      <a:pPr>
+                        <a:defRPr sz="1400" b="1">
+                          <a:solidFill>
+                            <a:srgbClr val="162D4E"/>
+                          </a:solidFill>
+                        </a:defRPr>
+                      </a:pPr>
+                      <a:r>
+                        <a:t>Train time</a:t>
+                      </a:r>
+                    </a:p>
+                  </a:txBody>
+                  <a:tcPr>
+                    <a:solidFill>
+                      <a:srgbClr val="E6EEF8"/>
+                    </a:solidFill>
+                  </a:tcPr>
+                </a:tc>
+              </a:tr>
+              <a:tr h="457200">
+                <a:tc>
+                  <a:txBody>
+                    <a:bodyPr/>
+                    <a:lstStyle/>
+                    <a:p>
+                      <a:pPr>
+                        <a:defRPr sz="1400" b="0">
+                          <a:solidFill>
+                            <a:srgbClr val="282828"/>
+                          </a:solidFill>
+                        </a:defRPr>
+                      </a:pPr>
+                      <a:r>
+                        <a:t>MLP</a:t>
+                      </a:r>
+                    </a:p>
+                  </a:txBody>
+                  <a:tcPr>
+                    <a:solidFill>
+                      <a:srgbClr val="FFFFFF"/>
+                    </a:solidFill>
+                  </a:tcPr>
+                </a:tc>
+                <a:tc>
+                  <a:txBody>
+                    <a:bodyPr/>
+                    <a:lstStyle/>
+                    <a:p>
+                      <a:pPr>
+                        <a:defRPr sz="1400" b="0">
+                          <a:solidFill>
+                            <a:srgbClr val="282828"/>
+                          </a:solidFill>
+                        </a:defRPr>
+                      </a:pPr>
+                      <a:r>
+                        <a:t>91.38%</a:t>
+                      </a:r>
+                    </a:p>
+                  </a:txBody>
+                  <a:tcPr>
+                    <a:solidFill>
+                      <a:srgbClr val="FFFFFF"/>
+                    </a:solidFill>
+                  </a:tcPr>
+                </a:tc>
+                <a:tc>
+                  <a:txBody>
+                    <a:bodyPr/>
+                    <a:lstStyle/>
+                    <a:p>
+                      <a:pPr>
+                        <a:defRPr sz="1400" b="0">
+                          <a:solidFill>
+                            <a:srgbClr val="282828"/>
+                          </a:solidFill>
+                        </a:defRPr>
+                      </a:pPr>
+                      <a:r>
+                        <a:t>0.9135</a:t>
+                      </a:r>
+                    </a:p>
+                  </a:txBody>
+                  <a:tcPr>
+                    <a:solidFill>
+                      <a:srgbClr val="FFFFFF"/>
+                    </a:solidFill>
+                  </a:tcPr>
+                </a:tc>
+                <a:tc>
+                  <a:txBody>
+                    <a:bodyPr/>
+                    <a:lstStyle/>
+                    <a:p>
+                      <a:pPr>
+                        <a:defRPr sz="1400" b="0">
+                          <a:solidFill>
+                            <a:srgbClr val="282828"/>
+                          </a:solidFill>
+                        </a:defRPr>
+                      </a:pPr>
+                      <a:r>
+                        <a:t>82s</a:t>
+                      </a:r>
+                    </a:p>
+                  </a:txBody>
+                  <a:tcPr>
+                    <a:solidFill>
+                      <a:srgbClr val="FFFFFF"/>
+                    </a:solidFill>
+                  </a:tcPr>
+                </a:tc>
+              </a:tr>
+              <a:tr h="457200">
+                <a:tc>
+                  <a:txBody>
+                    <a:bodyPr/>
+                    <a:lstStyle/>
+                    <a:p>
+                      <a:pPr>
+                        <a:defRPr sz="1400" b="0">
+                          <a:solidFill>
+                            <a:srgbClr val="282828"/>
+                          </a:solidFill>
+                        </a:defRPr>
+                      </a:pPr>
+                      <a:r>
+                        <a:t>CNN</a:t>
+                      </a:r>
+                    </a:p>
+                  </a:txBody>
+                  <a:tcPr>
+                    <a:solidFill>
+                      <a:srgbClr val="FFFFFF"/>
+                    </a:solidFill>
+                  </a:tcPr>
+                </a:tc>
+                <a:tc>
+                  <a:txBody>
+                    <a:bodyPr/>
+                    <a:lstStyle/>
+                    <a:p>
+                      <a:pPr>
+                        <a:defRPr sz="1400" b="0">
+                          <a:solidFill>
+                            <a:srgbClr val="282828"/>
+                          </a:solidFill>
+                        </a:defRPr>
+                      </a:pPr>
+                      <a:r>
+                        <a:t>91.79%</a:t>
+                      </a:r>
+                    </a:p>
+                  </a:txBody>
+                  <a:tcPr>
+                    <a:solidFill>
+                      <a:srgbClr val="FFFFFF"/>
+                    </a:solidFill>
+                  </a:tcPr>
+                </a:tc>
+                <a:tc>
+                  <a:txBody>
+                    <a:bodyPr/>
+                    <a:lstStyle/>
+                    <a:p>
+                      <a:pPr>
+                        <a:defRPr sz="1400" b="0">
+                          <a:solidFill>
+                            <a:srgbClr val="282828"/>
+                          </a:solidFill>
+                        </a:defRPr>
+                      </a:pPr>
+                      <a:r>
+                        <a:t>0.9189</a:t>
+                      </a:r>
+                    </a:p>
+                  </a:txBody>
+                  <a:tcPr>
+                    <a:solidFill>
+                      <a:srgbClr val="FFFFFF"/>
+                    </a:solidFill>
+                  </a:tcPr>
+                </a:tc>
+                <a:tc>
+                  <a:txBody>
+                    <a:bodyPr/>
+                    <a:lstStyle/>
+                    <a:p>
+                      <a:pPr>
+                        <a:defRPr sz="1400" b="0">
+                          <a:solidFill>
+                            <a:srgbClr val="282828"/>
+                          </a:solidFill>
+                        </a:defRPr>
+                      </a:pPr>
+                      <a:r>
+                        <a:t>529s</a:t>
+                      </a:r>
+                    </a:p>
+                  </a:txBody>
+                  <a:tcPr>
+                    <a:solidFill>
+                      <a:srgbClr val="FFFFFF"/>
+                    </a:solidFill>
+                  </a:tcPr>
+                </a:tc>
+              </a:tr>
+              <a:tr h="457200">
+                <a:tc>
+                  <a:txBody>
+                    <a:bodyPr/>
+                    <a:lstStyle/>
+                    <a:p>
+                      <a:pPr>
+                        <a:defRPr sz="1400" b="0">
+                          <a:solidFill>
+                            <a:srgbClr val="282828"/>
+                          </a:solidFill>
+                        </a:defRPr>
+                      </a:pPr>
+                      <a:r>
+                        <a:t>CNN-LSTM</a:t>
+                      </a:r>
+                    </a:p>
+                  </a:txBody>
+                  <a:tcPr>
+                    <a:solidFill>
+                      <a:srgbClr val="FFFFFF"/>
+                    </a:solidFill>
+                  </a:tcPr>
+                </a:tc>
+                <a:tc>
+                  <a:txBody>
+                    <a:bodyPr/>
+                    <a:lstStyle/>
+                    <a:p>
+                      <a:pPr>
+                        <a:defRPr sz="1400" b="0">
+                          <a:solidFill>
+                            <a:srgbClr val="282828"/>
+                          </a:solidFill>
+                        </a:defRPr>
+                      </a:pPr>
+                      <a:r>
+                        <a:t>93.25%</a:t>
+                      </a:r>
+                    </a:p>
+                  </a:txBody>
+                  <a:tcPr>
+                    <a:solidFill>
+                      <a:srgbClr val="FFFFFF"/>
+                    </a:solidFill>
+                  </a:tcPr>
+                </a:tc>
+                <a:tc>
+                  <a:txBody>
+                    <a:bodyPr/>
+                    <a:lstStyle/>
+                    <a:p>
+                      <a:pPr>
+                        <a:defRPr sz="1400" b="0">
+                          <a:solidFill>
+                            <a:srgbClr val="282828"/>
+                          </a:solidFill>
+                        </a:defRPr>
+                      </a:pPr>
+                      <a:r>
+                        <a:t>0.9335</a:t>
+                      </a:r>
+                    </a:p>
+                  </a:txBody>
+                  <a:tcPr>
+                    <a:solidFill>
+                      <a:srgbClr val="FFFFFF"/>
+                    </a:solidFill>
+                  </a:tcPr>
+                </a:tc>
+                <a:tc>
+                  <a:txBody>
+                    <a:bodyPr/>
+                    <a:lstStyle/>
+                    <a:p>
+                      <a:pPr>
+                        <a:defRPr sz="1400" b="0">
+                          <a:solidFill>
+                            <a:srgbClr val="282828"/>
+                          </a:solidFill>
+                        </a:defRPr>
+                      </a:pPr>
+                      <a:r>
+                        <a:t>829s</a:t>
+                      </a:r>
+                    </a:p>
+                  </a:txBody>
+                  <a:tcPr>
+                    <a:solidFill>
+                      <a:srgbClr val="FFFFFF"/>
+                    </a:solidFill>
+                  </a:tcPr>
+                </a:tc>
+              </a:tr>
+            </a:tbl>
+          </a:graphicData>
+        </a:graphic>
+      </p:graphicFrame>
+      <p:pic>
+        <p:nvPicPr>
+          <p:cNvPr id="7" name="Picture 6" descr="baseline_model_comparison.png"/>
+          <p:cNvPicPr>
+            <a:picLocks noChangeAspect="1"/>
+          </p:cNvPicPr>
+          <p:nvPr/>
+        </p:nvPicPr>
+        <p:blipFill>
+          <a:blip r:embed="rId2"/>
+          <a:stretch>
+            <a:fillRect/>
+          </a:stretch>
+        </p:blipFill>
+        <p:spPr>
+          <a:xfrm>
+            <a:off x="6400800" y="1234440"/>
+            <a:ext cx="5120640" cy="3200400"/>
+          </a:xfrm>
+          <a:prstGeom prst="rect">
+            <a:avLst/>
+          </a:prstGeom>
+        </p:spPr>
+      </p:pic>
+      <p:sp>
+        <p:nvSpPr>
+          <p:cNvPr id="8" name="TextBox 7"/>
+          <p:cNvSpPr txBox="1"/>
+          <p:nvPr/>
+        </p:nvSpPr>
+        <p:spPr>
+          <a:xfrm>
+            <a:off x="731520" y="3749039"/>
+            <a:ext cx="10789920" cy="1097280"/>
+          </a:xfrm>
+          <a:prstGeom prst="rect">
+            <a:avLst/>
+          </a:prstGeom>
+          <a:noFill/>
+        </p:spPr>
+        <p:txBody>
+          <a:bodyPr wrap="none">
+            <a:spAutoFit/>
+          </a:bodyPr>
+          <a:lstStyle/>
+          <a:p>
+            <a:pPr>
+              <a:defRPr sz="1800">
+                <a:solidFill>
+                  <a:srgbClr val="282828"/>
+                </a:solidFill>
+              </a:defRPr>
+            </a:pPr>
+            <a:r>
+              <a:t>Takeaway: sequence-aware CNN-LSTM improves over flattened MLP. Final work should compare TCN, attention, and sensor-transformer under the same split.</a:t>
             </a:r>
           </a:p>
         </p:txBody>
@@ -5454,7 +7087,7 @@
     <p:bg>
       <p:bgPr>
         <a:solidFill>
-          <a:srgbClr val="F8FAFC"/>
+          <a:srgbClr val="F7F9FC"/>
         </a:solidFill>
         <a:effectLst/>
       </p:bgPr>
@@ -5474,8 +7107,8 @@
         </p:nvSpPr>
         <p:spPr>
           <a:xfrm>
-            <a:off x="548640" y="320040"/>
-            <a:ext cx="11064240" cy="640080"/>
+            <a:off x="502920" y="320040"/>
+            <a:ext cx="11155680" cy="658368"/>
           </a:xfrm>
           <a:prstGeom prst="rect">
             <a:avLst/>
@@ -5488,27 +7121,69 @@
           </a:bodyPr>
           <a:lstStyle/>
           <a:p>
-            <a:r>
-              <a:rPr sz="3000" b="1">
-                <a:solidFill>
-                  <a:srgbClr val="182B4D"/>
-                </a:solidFill>
-              </a:rPr>
-              <a:t>MLOps and Demo</a:t>
-            </a:r>
-          </a:p>
-        </p:txBody>
-      </p:sp>
-      <p:sp>
-        <p:nvSpPr>
-          <p:cNvPr id="3" name="TextBox 2"/>
+            <a:pPr>
+              <a:defRPr b="1" sz="3000">
+                <a:solidFill>
+                  <a:srgbClr val="162D4E"/>
+                </a:solidFill>
+              </a:defRPr>
+            </a:pPr>
+            <a:r>
+              <a:t>Experiments and Ablations</a:t>
+            </a:r>
+          </a:p>
+        </p:txBody>
+      </p:sp>
+      <p:sp>
+        <p:nvSpPr>
+          <p:cNvPr id="3" name="Rectangle 2"/>
+          <p:cNvSpPr/>
+          <p:nvPr/>
+        </p:nvSpPr>
+        <p:spPr>
+          <a:xfrm>
+            <a:off x="502920" y="6446520"/>
+            <a:ext cx="11155680" cy="9144"/>
+          </a:xfrm>
+          <a:prstGeom prst="rect">
+            <a:avLst/>
+          </a:prstGeom>
+          <a:solidFill>
+            <a:srgbClr val="D2DCEB"/>
+          </a:solidFill>
+        </p:spPr>
+        <p:style>
+          <a:lnRef idx="1">
+            <a:schemeClr val="accent1"/>
+          </a:lnRef>
+          <a:fillRef idx="3">
+            <a:schemeClr val="accent1"/>
+          </a:fillRef>
+          <a:effectRef idx="2">
+            <a:schemeClr val="accent1"/>
+          </a:effectRef>
+          <a:fontRef idx="minor">
+            <a:schemeClr val="lt1"/>
+          </a:fontRef>
+        </p:style>
+        <p:txBody>
+          <a:bodyPr rtlCol="0" anchor="ctr"/>
+          <a:lstStyle/>
+          <a:p>
+            <a:pPr algn="ctr"/>
+          </a:p>
+        </p:txBody>
+      </p:sp>
+      <p:sp>
+        <p:nvSpPr>
+          <p:cNvPr id="4" name="TextBox 3"/>
           <p:cNvSpPr txBox="1"/>
           <p:nvPr/>
         </p:nvSpPr>
         <p:spPr>
           <a:xfrm>
-            <a:off x="566928" y="960120"/>
-            <a:ext cx="10972800" cy="320040"/>
+            <a:off x="548640" y="6473952"/>
+            <a:ext cx="10515600" cy="228600"/>
           </a:xfrm>
           <a:prstGeom prst="rect">
             <a:avLst/>
@@ -5521,27 +7196,29 @@
           </a:bodyPr>
           <a:lstStyle/>
           <a:p>
-            <a:r>
-              <a:rPr sz="1500">
-                <a:solidFill>
-                  <a:srgbClr val="282828"/>
-                </a:solidFill>
-              </a:rPr>
-              <a:t>Turning the notebook into a submission-ready system</a:t>
-            </a:r>
-          </a:p>
-        </p:txBody>
-      </p:sp>
-      <p:sp>
-        <p:nvSpPr>
-          <p:cNvPr id="4" name="TextBox 3"/>
+            <a:pPr>
+              <a:defRPr sz="900">
+                <a:solidFill>
+                  <a:srgbClr val="5F6978"/>
+                </a:solidFill>
+              </a:defRPr>
+            </a:pPr>
+            <a:r>
+              <a:t>DeepHAR-MLOps | CMPE Project | 9</a:t>
+            </a:r>
+          </a:p>
+        </p:txBody>
+      </p:sp>
+      <p:sp>
+        <p:nvSpPr>
+          <p:cNvPr id="5" name="TextBox 4"/>
           <p:cNvSpPr txBox="1"/>
           <p:nvPr/>
         </p:nvSpPr>
         <p:spPr>
           <a:xfrm>
-            <a:off x="731520" y="1417320"/>
-            <a:ext cx="10789920" cy="4480560"/>
+            <a:off x="777240" y="1417320"/>
+            <a:ext cx="10607040" cy="4754880"/>
           </a:xfrm>
           <a:prstGeom prst="rect">
             <a:avLst/>
@@ -5556,110 +7233,61 @@
           <a:p>
             <a:pPr>
               <a:spcAft>
-                <a:spcPts val="800"/>
+                <a:spcPts val="1000"/>
               </a:spcAft>
-              <a:defRPr sz="2000">
+              <a:defRPr sz="1900">
                 <a:solidFill>
                   <a:srgbClr val="282828"/>
                 </a:solidFill>
               </a:defRPr>
             </a:pPr>
             <a:r>
-              <a:t>Reusable train/evaluate/infer Python modules.</a:t>
+              <a:t>Architecture comparison: MLP, CNN, CNN-LSTM, TCN, attention, sensor-transformer.</a:t>
             </a:r>
           </a:p>
           <a:p>
             <a:pPr>
               <a:spcAft>
-                <a:spcPts val="800"/>
+                <a:spcPts val="1000"/>
               </a:spcAft>
-              <a:defRPr sz="2000">
+              <a:defRPr sz="1900">
                 <a:solidFill>
                   <a:srgbClr val="282828"/>
                 </a:solidFill>
               </a:defRPr>
             </a:pPr>
             <a:r>
-              <a:t>Saved checkpoints, normalizer, metrics, plots, and confusion matrices.</a:t>
+              <a:t>Sensor ablation: all sensors vs body accelerometer vs gyroscope vs total acceleration.</a:t>
             </a:r>
           </a:p>
           <a:p>
             <a:pPr>
               <a:spcAft>
-                <a:spcPts val="800"/>
+                <a:spcPts val="1000"/>
               </a:spcAft>
-              <a:defRPr sz="2000">
+              <a:defRPr sz="1900">
                 <a:solidFill>
                   <a:srgbClr val="282828"/>
                 </a:solidFill>
               </a:defRPr>
             </a:pPr>
             <a:r>
-              <a:t>MLflow and TensorBoard hooks for experiment tracking.</a:t>
+              <a:t>Augmentation ablation: no augmentation vs jitter/scaling/time masking.</a:t>
             </a:r>
           </a:p>
           <a:p>
             <a:pPr>
               <a:spcAft>
-                <a:spcPts val="800"/>
+                <a:spcPts val="1000"/>
               </a:spcAft>
-              <a:defRPr sz="2000">
+              <a:defRPr sz="1900">
                 <a:solidFill>
                   <a:srgbClr val="282828"/>
                 </a:solidFill>
               </a:defRPr>
             </a:pPr>
             <a:r>
-              <a:t>Gradio app for interactive inference from uploaded sensor windows.</a:t>
-            </a:r>
-          </a:p>
-          <a:p>
-            <a:pPr>
-              <a:spcAft>
-                <a:spcPts val="800"/>
-              </a:spcAft>
-              <a:defRPr sz="2000">
-                <a:solidFill>
-                  <a:srgbClr val="282828"/>
-                </a:solidFill>
-              </a:defRPr>
-            </a:pPr>
-            <a:r>
-              <a:t>Dockerfile and GitHub Actions smoke tests.</a:t>
-            </a:r>
-          </a:p>
-        </p:txBody>
-      </p:sp>
-      <p:sp>
-        <p:nvSpPr>
-          <p:cNvPr id="5" name="TextBox 4"/>
-          <p:cNvSpPr txBox="1"/>
-          <p:nvPr/>
-        </p:nvSpPr>
-        <p:spPr>
-          <a:xfrm>
-            <a:off x="548640" y="6446520"/>
-            <a:ext cx="11064240" cy="228600"/>
-          </a:xfrm>
-          <a:prstGeom prst="rect">
-            <a:avLst/>
-          </a:prstGeom>
-          <a:noFill/>
-        </p:spPr>
-        <p:txBody>
-          <a:bodyPr wrap="none">
-            <a:spAutoFit/>
-          </a:bodyPr>
-          <a:lstStyle/>
-          <a:p>
-            <a:pPr algn="r"/>
-            <a:r>
-              <a:rPr sz="900">
-                <a:solidFill>
-                  <a:srgbClr val="646E78"/>
-                </a:solidFill>
-              </a:rPr>
-              <a:t>CMPE 258 | DeepHAR-MLOps</a:t>
+              <a:t>Sweep: learning rate and batch size; report macro F1, latency, and parameter count.</a:t>
             </a:r>
           </a:p>
         </p:txBody>

</xml_diff>